<commit_message>
Further modifications to the Specification .md files and aligning the rest with the modifications
</commit_message>
<xml_diff>
--- a/Specifications/COMP1110_Basketball_Shot_Simulation_Progress.pptx
+++ b/Specifications/COMP1110_Basketball_Shot_Simulation_Progress.pptx
@@ -3386,7 +3386,7 @@
           </a:p>
           <a:p>
             <a:r>
-              <a:t>Bounce-in outcomes less accurate than swish</a:t>
+              <a:t>Rim-in and board-in outcomes less accurate than swish</a:t>
             </a:r>
           </a:p>
           <a:p>
@@ -3736,7 +3736,7 @@
           <a:lstStyle/>
           <a:p>
             <a:r>
-              <a:t>OpenPose work (Cao 2017, Chen 2020) corrects the shooter's posture.</a:t>
+              <a:t>OpenPose work (Cao 2017; Nakai et al. 2018) corrects the shooter's posture.</a:t>
             </a:r>
           </a:p>
           <a:p>
@@ -3744,7 +3744,7 @@
           </a:p>
           <a:p>
             <a:r>
-              <a:t>Classical models (Brancazio 1981, Alaways and Hubbard 2002) drop backspin or fuse the bounce outcomes.</a:t>
+              <a:t>Classical models (Brancazio 1981; Okubo &amp; Hubbard 2006) drop backspin or fuse the bounce outcomes.</a:t>
             </a:r>
           </a:p>
           <a:p>
@@ -3850,7 +3850,7 @@
           <a:lstStyle/>
           <a:p>
             <a:r>
-              <a:t>Can a simulation with a rigid board, rigid rim and one restitution constant e = 0.7 reproduce swish, board-and-in and miss?</a:t>
+              <a:t>Can a simulation with a rigid board, rigid rim and one restitution constant e = 0.7 reproduce swish, rim-in, board-in and miss?</a:t>
             </a:r>
           </a:p>
           <a:p>
@@ -4208,7 +4208,7 @@
           <a:lstStyle/>
           <a:p>
             <a:r>
-              <a:t>Grid sweep: 17 angles x 17 spin rates, 200 jittered shots per cell.</a:t>
+              <a:t>Grid sweep: 17 angles x 17 spin rates, 100 jittered shots per cell.</a:t>
             </a:r>
           </a:p>
           <a:p>
@@ -4216,7 +4216,7 @@
           </a:p>
           <a:p>
             <a:r>
-              <a:t>Peak P(make) = 0.86 near 51 degrees with 23 rad/s of backspin, split into 0.67 swish and 0.14 bounce-in.</a:t>
+              <a:t>Peak P(make) ≈ 0.77 near 55° with 45 rad/s of backspin, split across swish / rim-in / board-in.</a:t>
             </a:r>
           </a:p>
           <a:p>
@@ -4224,7 +4224,7 @@
           </a:p>
           <a:p>
             <a:r>
-              <a:t>Mean P climbs from 0.61 without spin to 0.69 at the top of the range.</a:t>
+              <a:t>Without spin P is lower, rising to a broad plateau (~15–45 rad/s).</a:t>
             </a:r>
           </a:p>
         </p:txBody>
@@ -4322,7 +4322,7 @@
           <a:lstStyle/>
           <a:p>
             <a:r>
-              <a:t>Air costs roughly 4 per cent more launch speed at both distances.</a:t>
+              <a:t>Air costs extra launch speed, and more at longer range.</a:t>
             </a:r>
           </a:p>
           <a:p>
@@ -4330,7 +4330,7 @@
           </a:p>
           <a:p>
             <a:r>
-              <a:t>Aim as if in a vacuum and the ball reaches the rim plane low: 34 cm on a free throw, 82 cm from three-point range.</a:t>
+              <a:t>Aim as if in a vacuum and the ball reaches the rim plane low: 40.2 cm on a free throw, 117 cm from three-point range.</a:t>
             </a:r>
           </a:p>
           <a:p>

</xml_diff>

<commit_message>
docs: add 2D simulator guide & physics notes, update progress deck
- SIMULATION_2D_GUIDE.md: usage guide for basketball_shot_2d.py (sliders, buttons, toggles, outcome reading)
- SIMULATION_2D_PHYSICS.md: model constants, RK4 + collision implementation, and constant differences vs the 3D pipeline
- update Specifications progress pptx and .bak to the desktop version
</commit_message>
<xml_diff>
--- a/Specifications/COMP1110_Basketball_Shot_Simulation_Progress.pptx
+++ b/Specifications/COMP1110_Basketball_Shot_Simulation_Progress.pptx
@@ -10,6 +10,11 @@
     <p:sldId id="258" r:id="rId4"/>
     <p:sldId id="259" r:id="rId5"/>
     <p:sldId id="260" r:id="rId6"/>
+    <p:sldId id="268" r:id="rId18"/>
+    <p:sldId id="269" r:id="rId19"/>
+    <p:sldId id="270" r:id="rId20"/>
+    <p:sldId id="271" r:id="rId21"/>
+    <p:sldId id="272" r:id="rId22"/>
     <p:sldId id="261" r:id="rId7"/>
     <p:sldId id="262" r:id="rId8"/>
     <p:sldId id="263" r:id="rId9"/>
@@ -313,7 +318,7 @@
           <a:p>
             <a:fld id="{5BCAD085-E8A6-8845-BD4E-CB4CCA059FC4}" type="datetimeFigureOut">
               <a:rPr lang="en-US" smtClean="0"/>
-              <a:t>10/20/2026</a:t>
+              <a:t>10/21/2026</a:t>
             </a:fld>
             <a:endParaRPr lang="en-US"/>
           </a:p>
@@ -481,7 +486,7 @@
           <a:p>
             <a:fld id="{5BCAD085-E8A6-8845-BD4E-CB4CCA059FC4}" type="datetimeFigureOut">
               <a:rPr lang="en-US" smtClean="0"/>
-              <a:t>10/20/2026</a:t>
+              <a:t>10/21/2026</a:t>
             </a:fld>
             <a:endParaRPr lang="en-US"/>
           </a:p>
@@ -659,7 +664,7 @@
           <a:p>
             <a:fld id="{5BCAD085-E8A6-8845-BD4E-CB4CCA059FC4}" type="datetimeFigureOut">
               <a:rPr lang="en-US" smtClean="0"/>
-              <a:t>10/20/2026</a:t>
+              <a:t>10/21/2026</a:t>
             </a:fld>
             <a:endParaRPr lang="en-US"/>
           </a:p>
@@ -827,7 +832,7 @@
           <a:p>
             <a:fld id="{5BCAD085-E8A6-8845-BD4E-CB4CCA059FC4}" type="datetimeFigureOut">
               <a:rPr lang="en-US" smtClean="0"/>
-              <a:t>10/20/2026</a:t>
+              <a:t>10/21/2026</a:t>
             </a:fld>
             <a:endParaRPr lang="en-US"/>
           </a:p>
@@ -1072,7 +1077,7 @@
           <a:p>
             <a:fld id="{5BCAD085-E8A6-8845-BD4E-CB4CCA059FC4}" type="datetimeFigureOut">
               <a:rPr lang="en-US" smtClean="0"/>
-              <a:t>10/20/2026</a:t>
+              <a:t>10/21/2026</a:t>
             </a:fld>
             <a:endParaRPr lang="en-US"/>
           </a:p>
@@ -1357,7 +1362,7 @@
           <a:p>
             <a:fld id="{5BCAD085-E8A6-8845-BD4E-CB4CCA059FC4}" type="datetimeFigureOut">
               <a:rPr lang="en-US" smtClean="0"/>
-              <a:t>10/20/2026</a:t>
+              <a:t>10/21/2026</a:t>
             </a:fld>
             <a:endParaRPr lang="en-US"/>
           </a:p>
@@ -1776,7 +1781,7 @@
           <a:p>
             <a:fld id="{5BCAD085-E8A6-8845-BD4E-CB4CCA059FC4}" type="datetimeFigureOut">
               <a:rPr lang="en-US" smtClean="0"/>
-              <a:t>10/20/2026</a:t>
+              <a:t>10/21/2026</a:t>
             </a:fld>
             <a:endParaRPr lang="en-US"/>
           </a:p>
@@ -1893,7 +1898,7 @@
           <a:p>
             <a:fld id="{5BCAD085-E8A6-8845-BD4E-CB4CCA059FC4}" type="datetimeFigureOut">
               <a:rPr lang="en-US" smtClean="0"/>
-              <a:t>10/20/2026</a:t>
+              <a:t>10/21/2026</a:t>
             </a:fld>
             <a:endParaRPr lang="en-US"/>
           </a:p>
@@ -1988,7 +1993,7 @@
           <a:p>
             <a:fld id="{5BCAD085-E8A6-8845-BD4E-CB4CCA059FC4}" type="datetimeFigureOut">
               <a:rPr lang="en-US" smtClean="0"/>
-              <a:t>10/20/2026</a:t>
+              <a:t>10/21/2026</a:t>
             </a:fld>
             <a:endParaRPr lang="en-US"/>
           </a:p>
@@ -2263,7 +2268,7 @@
           <a:p>
             <a:fld id="{5BCAD085-E8A6-8845-BD4E-CB4CCA059FC4}" type="datetimeFigureOut">
               <a:rPr lang="en-US" smtClean="0"/>
-              <a:t>10/20/2026</a:t>
+              <a:t>10/21/2026</a:t>
             </a:fld>
             <a:endParaRPr lang="en-US"/>
           </a:p>
@@ -2515,7 +2520,7 @@
           <a:p>
             <a:fld id="{5BCAD085-E8A6-8845-BD4E-CB4CCA059FC4}" type="datetimeFigureOut">
               <a:rPr lang="en-US" smtClean="0"/>
-              <a:t>10/20/2026</a:t>
+              <a:t>10/21/2026</a:t>
             </a:fld>
             <a:endParaRPr lang="en-US"/>
           </a:p>
@@ -2726,7 +2731,7 @@
           <a:p>
             <a:fld id="{5BCAD085-E8A6-8845-BD4E-CB4CCA059FC4}" type="datetimeFigureOut">
               <a:rPr lang="en-US" smtClean="0"/>
-              <a:t>10/20/2026</a:t>
+              <a:t>10/21/2026</a:t>
             </a:fld>
             <a:endParaRPr lang="en-US"/>
           </a:p>
@@ -3204,7 +3209,7 @@
 </file>
 
 <file path=ppt/slides/slide10.xml><?xml version="1.0" encoding="utf-8"?>
-<p:sld xmlns:a="http://schemas.openxmlformats.org/drawingml/2006/main" xmlns:r="http://schemas.openxmlformats.org/officeDocument/2006/relationships" xmlns:p="http://schemas.openxmlformats.org/presentationml/2006/main">
+<p:sld xmlns:a="http://schemas.openxmlformats.org/drawingml/2006/main" xmlns:p="http://schemas.openxmlformats.org/presentationml/2006/main" xmlns:r="http://schemas.openxmlformats.org/officeDocument/2006/relationships">
   <p:cSld>
     <p:spTree>
       <p:nvGrpSpPr>
@@ -3212,14 +3217,7 @@
         <p:cNvGrpSpPr/>
         <p:nvPr/>
       </p:nvGrpSpPr>
-      <p:grpSpPr>
-        <a:xfrm>
-          <a:off x="0" y="0"/>
-          <a:ext cx="0" cy="0"/>
-          <a:chOff x="0" y="0"/>
-          <a:chExt cx="0" cy="0"/>
-        </a:xfrm>
-      </p:grpSpPr>
+      <p:grpSpPr/>
       <p:sp>
         <p:nvSpPr>
           <p:cNvPr id="2" name="Title 1"/>
@@ -3236,35 +3234,375 @@
           <a:lstStyle/>
           <a:p>
             <a:r>
-              <a:t>Timeline and Current Progress</a:t>
-            </a:r>
-          </a:p>
-        </p:txBody>
-      </p:sp>
-      <p:pic>
-        <p:nvPicPr>
-          <p:cNvPr id="3" name="Picture 2" descr="fig_timeline.png"/>
-          <p:cNvPicPr>
-            <a:picLocks noChangeAspect="1"/>
-          </p:cNvPicPr>
+              <a:t>Quantitative Air and Vacuum Comparison</a:t>
+            </a:r>
+          </a:p>
+        </p:txBody>
+      </p:sp>
+      <p:graphicFrame>
+        <p:nvGraphicFramePr>
+          <p:cNvPr id="3" name="Table 2"/>
+          <p:cNvGraphicFramePr>
+            <a:graphicFrameLocks noGrp="1"/>
+          </p:cNvGraphicFramePr>
           <p:nvPr/>
-        </p:nvPicPr>
-        <p:blipFill>
-          <a:blip r:embed="rId2"/>
-          <a:stretch>
-            <a:fillRect/>
-          </a:stretch>
-        </p:blipFill>
-        <p:spPr>
-          <a:xfrm>
-            <a:off x="731520" y="1645920"/>
-            <a:ext cx="7772400" cy="4739268"/>
-          </a:xfrm>
-          <a:prstGeom prst="rect">
-            <a:avLst/>
-          </a:prstGeom>
-        </p:spPr>
-      </p:pic>
+        </p:nvGraphicFramePr>
+        <p:xfrm>
+          <a:off x="457200" y="1584000"/>
+          <a:ext cx="11016000" cy="3240000"/>
+        </p:xfrm>
+        <a:graphic>
+          <a:graphicData uri="http://schemas.openxmlformats.org/drawingml/2006/table">
+            <a:tbl>
+              <a:tblPr firstRow="1" bandRow="1">
+                <a:tableStyleId>{5C22544A-7EE6-4342-B048-85BDC9FD1C3A}</a:tableStyleId>
+              </a:tblPr>
+              <a:tblGrid>
+                <a:gridCol w="2880000"/>
+                <a:gridCol w="2160000"/>
+                <a:gridCol w="2340000"/>
+                <a:gridCol w="1080000"/>
+                <a:gridCol w="2556000"/>
+              </a:tblGrid>
+              <a:tr h="648000">
+                <a:tc>
+                  <a:txBody>
+                    <a:bodyPr/>
+                    <a:lstStyle/>
+                    <a:p>
+                      <a:r>
+                        <a:rPr b="1" sz="1100"/>
+                        <a:t>Shot</a:t>
+                      </a:r>
+                    </a:p>
+                  </a:txBody>
+                  <a:tcPr/>
+                </a:tc>
+                <a:tc>
+                  <a:txBody>
+                    <a:bodyPr/>
+                    <a:lstStyle/>
+                    <a:p>
+                      <a:r>
+                        <a:rPr b="1" sz="1100"/>
+                        <a:t>Vacuum aim speed</a:t>
+                      </a:r>
+                    </a:p>
+                  </a:txBody>
+                  <a:tcPr/>
+                </a:tc>
+                <a:tc>
+                  <a:txBody>
+                    <a:bodyPr/>
+                    <a:lstStyle/>
+                    <a:p>
+                      <a:r>
+                        <a:rPr b="1" sz="1100"/>
+                        <a:t>Model launch speed</a:t>
+                      </a:r>
+                    </a:p>
+                  </a:txBody>
+                  <a:tcPr/>
+                </a:tc>
+                <a:tc>
+                  <a:txBody>
+                    <a:bodyPr/>
+                    <a:lstStyle/>
+                    <a:p>
+                      <a:r>
+                        <a:rPr b="1" sz="1100"/>
+                        <a:t>Air cost</a:t>
+                      </a:r>
+                    </a:p>
+                  </a:txBody>
+                  <a:tcPr/>
+                </a:tc>
+                <a:tc>
+                  <a:txBody>
+                    <a:bodyPr/>
+                    <a:lstStyle/>
+                    <a:p>
+                      <a:r>
+                        <a:rPr b="1" sz="1100"/>
+                        <a:t>Vacuum aim lands below rim by</a:t>
+                      </a:r>
+                    </a:p>
+                  </a:txBody>
+                  <a:tcPr/>
+                </a:tc>
+              </a:tr>
+              <a:tr h="648000">
+                <a:tc>
+                  <a:txBody>
+                    <a:bodyPr/>
+                    <a:lstStyle/>
+                    <a:p>
+                      <a:r>
+                        <a:rPr sz="1100"/>
+                        <a:t>Free throw, 45 deg</a:t>
+                      </a:r>
+                    </a:p>
+                  </a:txBody>
+                  <a:tcPr/>
+                </a:tc>
+                <a:tc>
+                  <a:txBody>
+                    <a:bodyPr/>
+                    <a:lstStyle/>
+                    <a:p>
+                      <a:r>
+                        <a:rPr sz="1100"/>
+                        <a:t>7.65 m/s</a:t>
+                      </a:r>
+                    </a:p>
+                  </a:txBody>
+                  <a:tcPr/>
+                </a:tc>
+                <a:tc>
+                  <a:txBody>
+                    <a:bodyPr/>
+                    <a:lstStyle/>
+                    <a:p>
+                      <a:r>
+                        <a:rPr sz="1100"/>
+                        <a:t>8.02 m/s</a:t>
+                      </a:r>
+                    </a:p>
+                  </a:txBody>
+                  <a:tcPr/>
+                </a:tc>
+                <a:tc>
+                  <a:txBody>
+                    <a:bodyPr/>
+                    <a:lstStyle/>
+                    <a:p>
+                      <a:r>
+                        <a:rPr sz="1100"/>
+                        <a:t>+4.9 %</a:t>
+                      </a:r>
+                    </a:p>
+                  </a:txBody>
+                  <a:tcPr/>
+                </a:tc>
+                <a:tc>
+                  <a:txBody>
+                    <a:bodyPr/>
+                    <a:lstStyle/>
+                    <a:p>
+                      <a:r>
+                        <a:rPr sz="1100"/>
+                        <a:t>32 cm</a:t>
+                      </a:r>
+                    </a:p>
+                  </a:txBody>
+                  <a:tcPr/>
+                </a:tc>
+              </a:tr>
+              <a:tr h="648000">
+                <a:tc>
+                  <a:txBody>
+                    <a:bodyPr/>
+                    <a:lstStyle/>
+                    <a:p>
+                      <a:r>
+                        <a:rPr sz="1100"/>
+                        <a:t>Free throw, 51 deg</a:t>
+                      </a:r>
+                    </a:p>
+                  </a:txBody>
+                  <a:tcPr/>
+                </a:tc>
+                <a:tc>
+                  <a:txBody>
+                    <a:bodyPr/>
+                    <a:lstStyle/>
+                    <a:p>
+                      <a:r>
+                        <a:rPr sz="1100"/>
+                        <a:t>7.52 m/s</a:t>
+                      </a:r>
+                    </a:p>
+                  </a:txBody>
+                  <a:tcPr/>
+                </a:tc>
+                <a:tc>
+                  <a:txBody>
+                    <a:bodyPr/>
+                    <a:lstStyle/>
+                    <a:p>
+                      <a:r>
+                        <a:rPr sz="1100"/>
+                        <a:t>7.90 m/s</a:t>
+                      </a:r>
+                    </a:p>
+                  </a:txBody>
+                  <a:tcPr/>
+                </a:tc>
+                <a:tc>
+                  <a:txBody>
+                    <a:bodyPr/>
+                    <a:lstStyle/>
+                    <a:p>
+                      <a:r>
+                        <a:rPr sz="1100"/>
+                        <a:t>+5.0 %</a:t>
+                      </a:r>
+                    </a:p>
+                  </a:txBody>
+                  <a:tcPr/>
+                </a:tc>
+                <a:tc>
+                  <a:txBody>
+                    <a:bodyPr/>
+                    <a:lstStyle/>
+                    <a:p>
+                      <a:r>
+                        <a:rPr sz="1100"/>
+                        <a:t>44 cm</a:t>
+                      </a:r>
+                    </a:p>
+                  </a:txBody>
+                  <a:tcPr/>
+                </a:tc>
+              </a:tr>
+              <a:tr h="648000">
+                <a:tc>
+                  <a:txBody>
+                    <a:bodyPr/>
+                    <a:lstStyle/>
+                    <a:p>
+                      <a:r>
+                        <a:rPr sz="1100"/>
+                        <a:t>Three-point, 45 deg</a:t>
+                      </a:r>
+                    </a:p>
+                  </a:txBody>
+                  <a:tcPr/>
+                </a:tc>
+                <a:tc>
+                  <a:txBody>
+                    <a:bodyPr/>
+                    <a:lstStyle/>
+                    <a:p>
+                      <a:r>
+                        <a:rPr sz="1100"/>
+                        <a:t>8.86 m/s</a:t>
+                      </a:r>
+                    </a:p>
+                  </a:txBody>
+                  <a:tcPr/>
+                </a:tc>
+                <a:tc>
+                  <a:txBody>
+                    <a:bodyPr/>
+                    <a:lstStyle/>
+                    <a:p>
+                      <a:r>
+                        <a:rPr sz="1100"/>
+                        <a:t>9.46 m/s</a:t>
+                      </a:r>
+                    </a:p>
+                  </a:txBody>
+                  <a:tcPr/>
+                </a:tc>
+                <a:tc>
+                  <a:txBody>
+                    <a:bodyPr/>
+                    <a:lstStyle/>
+                    <a:p>
+                      <a:r>
+                        <a:rPr sz="1100"/>
+                        <a:t>+6.8 %</a:t>
+                      </a:r>
+                    </a:p>
+                  </a:txBody>
+                  <a:tcPr/>
+                </a:tc>
+                <a:tc>
+                  <a:txBody>
+                    <a:bodyPr/>
+                    <a:lstStyle/>
+                    <a:p>
+                      <a:r>
+                        <a:rPr sz="1100"/>
+                        <a:t>75 cm</a:t>
+                      </a:r>
+                    </a:p>
+                  </a:txBody>
+                  <a:tcPr/>
+                </a:tc>
+              </a:tr>
+              <a:tr h="648000">
+                <a:tc>
+                  <a:txBody>
+                    <a:bodyPr/>
+                    <a:lstStyle/>
+                    <a:p>
+                      <a:r>
+                        <a:rPr sz="1100"/>
+                        <a:t>Three-point, 51 deg</a:t>
+                      </a:r>
+                    </a:p>
+                  </a:txBody>
+                  <a:tcPr/>
+                </a:tc>
+                <a:tc>
+                  <a:txBody>
+                    <a:bodyPr/>
+                    <a:lstStyle/>
+                    <a:p>
+                      <a:r>
+                        <a:rPr sz="1100"/>
+                        <a:t>8.80 m/s</a:t>
+                      </a:r>
+                    </a:p>
+                  </a:txBody>
+                  <a:tcPr/>
+                </a:tc>
+                <a:tc>
+                  <a:txBody>
+                    <a:bodyPr/>
+                    <a:lstStyle/>
+                    <a:p>
+                      <a:r>
+                        <a:rPr sz="1100"/>
+                        <a:t>9.40 m/s</a:t>
+                      </a:r>
+                    </a:p>
+                  </a:txBody>
+                  <a:tcPr/>
+                </a:tc>
+                <a:tc>
+                  <a:txBody>
+                    <a:bodyPr/>
+                    <a:lstStyle/>
+                    <a:p>
+                      <a:r>
+                        <a:rPr sz="1100"/>
+                        <a:t>+6.8 %</a:t>
+                      </a:r>
+                    </a:p>
+                  </a:txBody>
+                  <a:tcPr/>
+                </a:tc>
+                <a:tc>
+                  <a:txBody>
+                    <a:bodyPr/>
+                    <a:lstStyle/>
+                    <a:p>
+                      <a:r>
+                        <a:rPr sz="1100"/>
+                        <a:t>101 cm</a:t>
+                      </a:r>
+                    </a:p>
+                  </a:txBody>
+                  <a:tcPr/>
+                </a:tc>
+              </a:tr>
+            </a:tbl>
+          </a:graphicData>
+        </a:graphic>
+      </p:graphicFrame>
       <p:sp>
         <p:nvSpPr>
           <p:cNvPr id="4" name="TextBox 3"/>
@@ -3273,8 +3611,8 @@
         </p:nvSpPr>
         <p:spPr>
           <a:xfrm>
-            <a:off x="8778240" y="2011680"/>
-            <a:ext cx="2926080" cy="4114800"/>
+            <a:off x="457200" y="5004000"/>
+            <a:ext cx="11016000" cy="2160000"/>
           </a:xfrm>
           <a:prstGeom prst="rect">
             <a:avLst/>
@@ -3282,29 +3620,32 @@
           <a:noFill/>
         </p:spPr>
         <p:txBody>
-          <a:bodyPr wrap="none">
+          <a:bodyPr wrap="square">
             <a:spAutoFit/>
           </a:bodyPr>
           <a:lstStyle/>
           <a:p>
             <a:r>
-              <a:t>Phase 1, literature review and model design, is complete.</a:t>
-            </a:r>
-          </a:p>
-          <a:p>
-            <a:endParaRPr/>
-          </a:p>
-          <a:p>
-            <a:r>
-              <a:t>Phase 2, the RK4 integrator and the collision code, is in progress this week.</a:t>
-            </a:r>
-          </a:p>
-          <a:p>
-            <a:endParaRPr/>
-          </a:p>
-          <a:p>
-            <a:r>
-              <a:t>Extension and footage labels follow in weeks 7 to 9; writing and figures in weeks 10 to 12.</a:t>
+              <a:rPr sz="1200"/>
+              <a:t>Model launch speed (drag + Magnus) against the same-angle vacuum</a:t>
+            </a:r>
+          </a:p>
+          <a:p>
+            <a:r>
+              <a:rPr sz="1200"/>
+              <a:t>aim. Air raises the required speed by roughly 5 % at the free throw</a:t>
+            </a:r>
+          </a:p>
+          <a:p>
+            <a:r>
+              <a:rPr sz="1200"/>
+              <a:t>and 7 % at three-point range, and a vacuum-aimed shot reaches the</a:t>
+            </a:r>
+          </a:p>
+          <a:p>
+            <a:r>
+              <a:rPr sz="1200"/>
+              <a:t>rim plane increasingly low with distance - supporting the extension.</a:t>
             </a:r>
           </a:p>
         </p:txBody>
@@ -3350,7 +3691,7 @@
           <a:lstStyle/>
           <a:p>
             <a:r>
-              <a:t>Stated Limitations and Ethics</a:t>
+              <a:t>Scope Boundaries</a:t>
             </a:r>
           </a:p>
         </p:txBody>
@@ -3371,27 +3712,32 @@
           <a:lstStyle/>
           <a:p>
             <a:r>
-              <a:t>Real rims flex, real boards vibrate</a:t>
-            </a:r>
-          </a:p>
-          <a:p>
-            <a:r>
-              <a:t>One restitution constant for two contacts</a:t>
-            </a:r>
-          </a:p>
-          <a:p>
-            <a:r>
-              <a:t>Spin held constant, no decay in flight</a:t>
-            </a:r>
-          </a:p>
-          <a:p>
-            <a:r>
-              <a:t>Rim-in and board-in outcomes less accurate than swish</a:t>
-            </a:r>
-          </a:p>
-          <a:p>
-            <a:r>
-              <a:t>Small empirical sample</a:t>
+              <a:t>Release point, velocity vector, backspin</a:t>
+            </a:r>
+          </a:p>
+          <a:p>
+            <a:r>
+              <a:t>Quadratic air drag + Magnus lift</a:t>
+            </a:r>
+          </a:p>
+          <a:p>
+            <a:r>
+              <a:t>Rigid vertical board plane</a:t>
+            </a:r>
+          </a:p>
+          <a:p>
+            <a:r>
+              <a:t>Rigid rim, inelastic contact e = 0.7</a:t>
+            </a:r>
+          </a:p>
+          <a:p>
+            <a:r>
+              <a:t>Swish, rim-in, board-in, miss</a:t>
+            </a:r>
+          </a:p>
+          <a:p>
+            <a:r>
+              <a:t>Free-throw versus 3-point extension</a:t>
             </a:r>
           </a:p>
         </p:txBody>
@@ -3412,27 +3758,32 @@
           <a:lstStyle/>
           <a:p>
             <a:r>
-              <a:t>Filmed participants are team members</a:t>
-            </a:r>
-          </a:p>
-          <a:p>
-            <a:r>
-              <a:t>Verbal consent, footage stays local</a:t>
-            </a:r>
-          </a:p>
-          <a:p>
-            <a:r>
-              <a:t>Outcomes labelled, no face data needed</a:t>
-            </a:r>
-          </a:p>
-          <a:p>
-            <a:r>
-              <a:t>Video deleted after the final report</a:t>
-            </a:r>
-          </a:p>
-          <a:p>
-            <a:r>
-              <a:t>SportVU data is public and anonymised</a:t>
+              <a:t>Ball deformation, rim flex, board vibration</a:t>
+            </a:r>
+          </a:p>
+          <a:p>
+            <a:r>
+              <a:t>Player fatigue and psychology</a:t>
+            </a:r>
+          </a:p>
+          <a:p>
+            <a:r>
+              <a:t>Side-spin and wobble</a:t>
+            </a:r>
+          </a:p>
+          <a:p>
+            <a:r>
+              <a:t>Machine-learning correction of the physics</a:t>
+            </a:r>
+          </a:p>
+          <a:p>
+            <a:r>
+              <a:t>Real-time pose estimation</a:t>
+            </a:r>
+          </a:p>
+          <a:p>
+            <a:r>
+              <a:t>Claims about real players' performance</a:t>
             </a:r>
           </a:p>
         </p:txBody>
@@ -3478,6 +3829,636 @@
           <a:lstStyle/>
           <a:p>
             <a:r>
+              <a:t>Early Result: Make-Probability Surface</a:t>
+            </a:r>
+          </a:p>
+        </p:txBody>
+      </p:sp>
+      <p:pic>
+        <p:nvPicPr>
+          <p:cNvPr id="3" name="Picture 2" descr="fig_heatmap.png"/>
+          <p:cNvPicPr>
+            <a:picLocks noChangeAspect="1"/>
+          </p:cNvPicPr>
+          <p:nvPr/>
+        </p:nvPicPr>
+        <p:blipFill>
+          <a:blip r:embed="rId2"/>
+          <a:stretch>
+            <a:fillRect/>
+          </a:stretch>
+        </p:blipFill>
+        <p:spPr>
+          <a:xfrm>
+            <a:off x="731520" y="1645920"/>
+            <a:ext cx="7772400" cy="4739268"/>
+          </a:xfrm>
+          <a:prstGeom prst="rect">
+            <a:avLst/>
+          </a:prstGeom>
+        </p:spPr>
+      </p:pic>
+      <p:sp>
+        <p:nvSpPr>
+          <p:cNvPr id="4" name="TextBox 3"/>
+          <p:cNvSpPr txBox="1"/>
+          <p:nvPr/>
+        </p:nvSpPr>
+        <p:spPr>
+          <a:xfrm>
+            <a:off x="8778240" y="2011680"/>
+            <a:ext cx="3203228" cy="3139321"/>
+          </a:xfrm>
+          <a:prstGeom prst="rect">
+            <a:avLst/>
+          </a:prstGeom>
+          <a:noFill/>
+        </p:spPr>
+        <p:txBody>
+          <a:bodyPr wrap="square">
+            <a:spAutoFit/>
+          </a:bodyPr>
+          <a:lstStyle/>
+          <a:p>
+            <a:r>
+              <a:rPr dirty="0"/>
+              <a:t>Grid sweep: 17 angles x 17 spin rates, 200 jittered shots per cell.</a:t>
+            </a:r>
+          </a:p>
+          <a:p>
+            <a:endParaRPr dirty="0"/>
+          </a:p>
+          <a:p>
+            <a:r>
+              <a:rPr dirty="0"/>
+              <a:t>Peak P(make) = 0.86 near 51 degrees with 23 rad/s of backspin, split into 0.67 swish and 0.14 bounce-in.</a:t>
+            </a:r>
+          </a:p>
+          <a:p>
+            <a:endParaRPr dirty="0"/>
+          </a:p>
+          <a:p>
+            <a:r>
+              <a:rPr dirty="0"/>
+              <a:t>Mean P climbs from 0.61 without spin to 0.69 at the top of the range.</a:t>
+            </a:r>
+          </a:p>
+        </p:txBody>
+      </p:sp>
+    </p:spTree>
+  </p:cSld>
+  <p:clrMapOvr>
+    <a:masterClrMapping/>
+  </p:clrMapOvr>
+</p:sld>
+</file>
+
+<file path=ppt/slides/slide13.xml><?xml version="1.0" encoding="utf-8"?>
+<p:sld xmlns:a="http://schemas.openxmlformats.org/drawingml/2006/main" xmlns:r="http://schemas.openxmlformats.org/officeDocument/2006/relationships" xmlns:p="http://schemas.openxmlformats.org/presentationml/2006/main">
+  <p:cSld>
+    <p:spTree>
+      <p:nvGrpSpPr>
+        <p:cNvPr id="1" name=""/>
+        <p:cNvGrpSpPr/>
+        <p:nvPr/>
+      </p:nvGrpSpPr>
+      <p:grpSpPr>
+        <a:xfrm>
+          <a:off x="0" y="0"/>
+          <a:ext cx="0" cy="0"/>
+          <a:chOff x="0" y="0"/>
+          <a:chExt cx="0" cy="0"/>
+        </a:xfrm>
+      </p:grpSpPr>
+      <p:sp>
+        <p:nvSpPr>
+          <p:cNvPr id="2" name="Title 1"/>
+          <p:cNvSpPr>
+            <a:spLocks noGrp="1"/>
+          </p:cNvSpPr>
+          <p:nvPr>
+            <p:ph type="title"/>
+          </p:nvPr>
+        </p:nvSpPr>
+        <p:spPr/>
+        <p:txBody>
+          <a:bodyPr/>
+          <a:lstStyle/>
+          <a:p>
+            <a:r>
+              <a:t>Extension: Free Throw versus 3-Point</a:t>
+            </a:r>
+          </a:p>
+        </p:txBody>
+      </p:sp>
+      <p:pic>
+        <p:nvPicPr>
+          <p:cNvPr id="3" name="Picture 2" descr="fig_ft3p.png"/>
+          <p:cNvPicPr>
+            <a:picLocks noChangeAspect="1"/>
+          </p:cNvPicPr>
+          <p:nvPr/>
+        </p:nvPicPr>
+        <p:blipFill>
+          <a:blip r:embed="rId2"/>
+          <a:stretch>
+            <a:fillRect/>
+          </a:stretch>
+        </p:blipFill>
+        <p:spPr>
+          <a:xfrm>
+            <a:off x="731520" y="1645920"/>
+            <a:ext cx="7772400" cy="4739268"/>
+          </a:xfrm>
+          <a:prstGeom prst="rect">
+            <a:avLst/>
+          </a:prstGeom>
+        </p:spPr>
+      </p:pic>
+      <p:sp>
+        <p:nvSpPr>
+          <p:cNvPr id="4" name="TextBox 3"/>
+          <p:cNvSpPr txBox="1"/>
+          <p:nvPr/>
+        </p:nvSpPr>
+        <p:spPr>
+          <a:xfrm>
+            <a:off x="8778240" y="2011679"/>
+            <a:ext cx="2682240" cy="3416320"/>
+          </a:xfrm>
+          <a:prstGeom prst="rect">
+            <a:avLst/>
+          </a:prstGeom>
+          <a:noFill/>
+        </p:spPr>
+        <p:txBody>
+          <a:bodyPr wrap="square">
+            <a:spAutoFit/>
+          </a:bodyPr>
+          <a:lstStyle/>
+          <a:p>
+            <a:r>
+              <a:rPr sz="1500"/>
+              <a:t>Air raises the minimum launch speed by about 5 per cent at the free</a:t>
+            </a:r>
+          </a:p>
+          <a:p>
+            <a:r>
+              <a:rPr sz="1500"/>
+              <a:t>throw and 7 per cent from three-point range, as tabulated on the</a:t>
+            </a:r>
+          </a:p>
+          <a:p>
+            <a:r>
+              <a:rPr sz="1500"/>
+              <a:t>Quantitative Air and Vacuum Comparison slide earlier in this deck.</a:t>
+            </a:r>
+          </a:p>
+          <a:p/>
+          <a:p>
+            <a:r>
+              <a:rPr sz="1500"/>
+              <a:t>Aim the same angle as if in a vacuum and the ball meets the rim</a:t>
+            </a:r>
+          </a:p>
+          <a:p>
+            <a:r>
+              <a:rPr sz="1500"/>
+              <a:t>plane low: about 32 cm on a free throw and 75 cm from three-point</a:t>
+            </a:r>
+          </a:p>
+          <a:p>
+            <a:r>
+              <a:rPr sz="1500"/>
+              <a:t>range at 45 deg; 44 cm and 101 cm at 51 deg.</a:t>
+            </a:r>
+          </a:p>
+          <a:p/>
+          <a:p>
+            <a:r>
+              <a:rPr sz="1500"/>
+              <a:t>Drag and spin act for longer the farther the shot, so their effect</a:t>
+            </a:r>
+          </a:p>
+          <a:p>
+            <a:r>
+              <a:rPr sz="1500"/>
+              <a:t>grows with distance.</a:t>
+            </a:r>
+          </a:p>
+        </p:txBody>
+      </p:sp>
+    </p:spTree>
+  </p:cSld>
+  <p:clrMapOvr>
+    <a:masterClrMapping/>
+  </p:clrMapOvr>
+</p:sld>
+</file>
+
+<file path=ppt/slides/slide14.xml><?xml version="1.0" encoding="utf-8"?>
+<p:sld xmlns:a="http://schemas.openxmlformats.org/drawingml/2006/main" xmlns:r="http://schemas.openxmlformats.org/officeDocument/2006/relationships" xmlns:p="http://schemas.openxmlformats.org/presentationml/2006/main">
+  <p:cSld>
+    <p:spTree>
+      <p:nvGrpSpPr>
+        <p:cNvPr id="1" name=""/>
+        <p:cNvGrpSpPr/>
+        <p:nvPr/>
+      </p:nvGrpSpPr>
+      <p:grpSpPr>
+        <a:xfrm>
+          <a:off x="0" y="0"/>
+          <a:ext cx="0" cy="0"/>
+          <a:chOff x="0" y="0"/>
+          <a:chExt cx="0" cy="0"/>
+        </a:xfrm>
+      </p:grpSpPr>
+      <p:sp>
+        <p:nvSpPr>
+          <p:cNvPr id="2" name="Title 1"/>
+          <p:cNvSpPr>
+            <a:spLocks noGrp="1"/>
+          </p:cNvSpPr>
+          <p:nvPr>
+            <p:ph type="title"/>
+          </p:nvPr>
+        </p:nvSpPr>
+        <p:spPr/>
+        <p:txBody>
+          <a:bodyPr/>
+          <a:lstStyle/>
+          <a:p>
+            <a:r>
+              <a:t>Validation Design</a:t>
+            </a:r>
+          </a:p>
+        </p:txBody>
+      </p:sp>
+      <p:pic>
+        <p:nvPicPr>
+          <p:cNvPr id="3" name="Picture 2" descr="fig_validation.png"/>
+          <p:cNvPicPr>
+            <a:picLocks noChangeAspect="1"/>
+          </p:cNvPicPr>
+          <p:nvPr/>
+        </p:nvPicPr>
+        <p:blipFill>
+          <a:blip r:embed="rId2"/>
+          <a:stretch>
+            <a:fillRect/>
+          </a:stretch>
+        </p:blipFill>
+        <p:spPr>
+          <a:xfrm>
+            <a:off x="731520" y="1645920"/>
+            <a:ext cx="7772400" cy="4739268"/>
+          </a:xfrm>
+          <a:prstGeom prst="rect">
+            <a:avLst/>
+          </a:prstGeom>
+        </p:spPr>
+      </p:pic>
+      <p:sp>
+        <p:nvSpPr>
+          <p:cNvPr id="4" name="TextBox 3"/>
+          <p:cNvSpPr txBox="1"/>
+          <p:nvPr/>
+        </p:nvSpPr>
+        <p:spPr>
+          <a:xfrm>
+            <a:off x="8778240" y="2011680"/>
+            <a:ext cx="2845010" cy="3693319"/>
+          </a:xfrm>
+          <a:prstGeom prst="rect">
+            <a:avLst/>
+          </a:prstGeom>
+          <a:noFill/>
+        </p:spPr>
+        <p:txBody>
+          <a:bodyPr wrap="square">
+            <a:spAutoFit/>
+          </a:bodyPr>
+          <a:lstStyle/>
+          <a:p>
+            <a:r>
+              <a:rPr dirty="0"/>
+              <a:t>20 to 30 group-member free throws filmed at 60 fps, plus public NBA </a:t>
+            </a:r>
+            <a:r>
+              <a:rPr dirty="0" err="1"/>
+              <a:t>SportVU</a:t>
+            </a:r>
+            <a:r>
+              <a:rPr dirty="0"/>
+              <a:t> tracking.</a:t>
+            </a:r>
+          </a:p>
+          <a:p>
+            <a:endParaRPr dirty="0"/>
+          </a:p>
+          <a:p>
+            <a:r>
+              <a:rPr dirty="0"/>
+              <a:t>Frame by frame tracking gives release geometry and the recorded outcome class.</a:t>
+            </a:r>
+          </a:p>
+          <a:p>
+            <a:endParaRPr dirty="0"/>
+          </a:p>
+          <a:p>
+            <a:r>
+              <a:rPr dirty="0"/>
+              <a:t>We report a single disagreement rate, as a sanity check rather than a statistical claim.</a:t>
+            </a:r>
+          </a:p>
+        </p:txBody>
+      </p:sp>
+    </p:spTree>
+  </p:cSld>
+  <p:clrMapOvr>
+    <a:masterClrMapping/>
+  </p:clrMapOvr>
+</p:sld>
+</file>
+
+<file path=ppt/slides/slide15.xml><?xml version="1.0" encoding="utf-8"?>
+<p:sld xmlns:a="http://schemas.openxmlformats.org/drawingml/2006/main" xmlns:r="http://schemas.openxmlformats.org/officeDocument/2006/relationships" xmlns:p="http://schemas.openxmlformats.org/presentationml/2006/main">
+  <p:cSld>
+    <p:spTree>
+      <p:nvGrpSpPr>
+        <p:cNvPr id="1" name=""/>
+        <p:cNvGrpSpPr/>
+        <p:nvPr/>
+      </p:nvGrpSpPr>
+      <p:grpSpPr>
+        <a:xfrm>
+          <a:off x="0" y="0"/>
+          <a:ext cx="0" cy="0"/>
+          <a:chOff x="0" y="0"/>
+          <a:chExt cx="0" cy="0"/>
+        </a:xfrm>
+      </p:grpSpPr>
+      <p:sp>
+        <p:nvSpPr>
+          <p:cNvPr id="2" name="Title 1"/>
+          <p:cNvSpPr>
+            <a:spLocks noGrp="1"/>
+          </p:cNvSpPr>
+          <p:nvPr>
+            <p:ph type="title"/>
+          </p:nvPr>
+        </p:nvSpPr>
+        <p:spPr/>
+        <p:txBody>
+          <a:bodyPr/>
+          <a:lstStyle/>
+          <a:p>
+            <a:r>
+              <a:t>Timeline and Current Progress</a:t>
+            </a:r>
+          </a:p>
+        </p:txBody>
+      </p:sp>
+      <p:pic>
+        <p:nvPicPr>
+          <p:cNvPr id="3" name="Picture 2" descr="fig_timeline.png"/>
+          <p:cNvPicPr>
+            <a:picLocks noChangeAspect="1"/>
+          </p:cNvPicPr>
+          <p:nvPr/>
+        </p:nvPicPr>
+        <p:blipFill>
+          <a:blip r:embed="rId2"/>
+          <a:stretch>
+            <a:fillRect/>
+          </a:stretch>
+        </p:blipFill>
+        <p:spPr>
+          <a:xfrm>
+            <a:off x="731520" y="1645920"/>
+            <a:ext cx="7772400" cy="4739268"/>
+          </a:xfrm>
+          <a:prstGeom prst="rect">
+            <a:avLst/>
+          </a:prstGeom>
+        </p:spPr>
+      </p:pic>
+      <p:sp>
+        <p:nvSpPr>
+          <p:cNvPr id="4" name="TextBox 3"/>
+          <p:cNvSpPr txBox="1"/>
+          <p:nvPr/>
+        </p:nvSpPr>
+        <p:spPr>
+          <a:xfrm>
+            <a:off x="8778240" y="2011680"/>
+            <a:ext cx="3071254" cy="2862322"/>
+          </a:xfrm>
+          <a:prstGeom prst="rect">
+            <a:avLst/>
+          </a:prstGeom>
+          <a:noFill/>
+        </p:spPr>
+        <p:txBody>
+          <a:bodyPr wrap="square">
+            <a:spAutoFit/>
+          </a:bodyPr>
+          <a:lstStyle/>
+          <a:p>
+            <a:r>
+              <a:rPr dirty="0"/>
+              <a:t>Phase 1, literature review and model design, is complete.</a:t>
+            </a:r>
+          </a:p>
+          <a:p>
+            <a:endParaRPr dirty="0"/>
+          </a:p>
+          <a:p>
+            <a:r>
+              <a:rPr dirty="0"/>
+              <a:t>Phase 2, the RK4 integrator and the collision code, is in progress this week.</a:t>
+            </a:r>
+          </a:p>
+          <a:p>
+            <a:endParaRPr dirty="0"/>
+          </a:p>
+          <a:p>
+            <a:r>
+              <a:rPr dirty="0"/>
+              <a:t>Extension and footage labels follow in weeks 7 to 9; writing and figures in weeks 10 to 12.</a:t>
+            </a:r>
+          </a:p>
+        </p:txBody>
+      </p:sp>
+    </p:spTree>
+  </p:cSld>
+  <p:clrMapOvr>
+    <a:masterClrMapping/>
+  </p:clrMapOvr>
+</p:sld>
+</file>
+
+<file path=ppt/slides/slide16.xml><?xml version="1.0" encoding="utf-8"?>
+<p:sld xmlns:a="http://schemas.openxmlformats.org/drawingml/2006/main" xmlns:r="http://schemas.openxmlformats.org/officeDocument/2006/relationships" xmlns:p="http://schemas.openxmlformats.org/presentationml/2006/main">
+  <p:cSld>
+    <p:spTree>
+      <p:nvGrpSpPr>
+        <p:cNvPr id="1" name=""/>
+        <p:cNvGrpSpPr/>
+        <p:nvPr/>
+      </p:nvGrpSpPr>
+      <p:grpSpPr>
+        <a:xfrm>
+          <a:off x="0" y="0"/>
+          <a:ext cx="0" cy="0"/>
+          <a:chOff x="0" y="0"/>
+          <a:chExt cx="0" cy="0"/>
+        </a:xfrm>
+      </p:grpSpPr>
+      <p:sp>
+        <p:nvSpPr>
+          <p:cNvPr id="2" name="Title 1"/>
+          <p:cNvSpPr>
+            <a:spLocks noGrp="1"/>
+          </p:cNvSpPr>
+          <p:nvPr>
+            <p:ph type="title"/>
+          </p:nvPr>
+        </p:nvSpPr>
+        <p:spPr/>
+        <p:txBody>
+          <a:bodyPr/>
+          <a:lstStyle/>
+          <a:p>
+            <a:r>
+              <a:t>Stated Limitations and Ethics</a:t>
+            </a:r>
+          </a:p>
+        </p:txBody>
+      </p:sp>
+      <p:sp>
+        <p:nvSpPr>
+          <p:cNvPr id="3" name="Content Placeholder 2"/>
+          <p:cNvSpPr>
+            <a:spLocks noGrp="1"/>
+          </p:cNvSpPr>
+          <p:nvPr>
+            <p:ph sz="half" idx="1"/>
+          </p:nvPr>
+        </p:nvSpPr>
+        <p:spPr/>
+        <p:txBody>
+          <a:bodyPr/>
+          <a:lstStyle/>
+          <a:p>
+            <a:r>
+              <a:t>Real rims flex, real boards vibrate</a:t>
+            </a:r>
+          </a:p>
+          <a:p>
+            <a:r>
+              <a:t>One restitution constant for two contacts</a:t>
+            </a:r>
+          </a:p>
+          <a:p>
+            <a:r>
+              <a:t>Spin held constant, no decay in flight</a:t>
+            </a:r>
+          </a:p>
+          <a:p>
+            <a:r>
+              <a:t>Bounce-in outcomes less accurate than swish</a:t>
+            </a:r>
+          </a:p>
+          <a:p>
+            <a:r>
+              <a:t>Small empirical sample</a:t>
+            </a:r>
+          </a:p>
+        </p:txBody>
+      </p:sp>
+      <p:sp>
+        <p:nvSpPr>
+          <p:cNvPr id="4" name="Content Placeholder 3"/>
+          <p:cNvSpPr>
+            <a:spLocks noGrp="1"/>
+          </p:cNvSpPr>
+          <p:nvPr>
+            <p:ph sz="half" idx="2"/>
+          </p:nvPr>
+        </p:nvSpPr>
+        <p:spPr/>
+        <p:txBody>
+          <a:bodyPr/>
+          <a:lstStyle/>
+          <a:p>
+            <a:r>
+              <a:t>Filmed participants are team members</a:t>
+            </a:r>
+          </a:p>
+          <a:p>
+            <a:r>
+              <a:t>Verbal consent, footage stays local</a:t>
+            </a:r>
+          </a:p>
+          <a:p>
+            <a:r>
+              <a:t>Outcomes labelled, no face data needed</a:t>
+            </a:r>
+          </a:p>
+          <a:p>
+            <a:r>
+              <a:t>Video deleted after the final report</a:t>
+            </a:r>
+          </a:p>
+          <a:p>
+            <a:r>
+              <a:t>SportVU data is public and anonymised</a:t>
+            </a:r>
+          </a:p>
+        </p:txBody>
+      </p:sp>
+    </p:spTree>
+  </p:cSld>
+  <p:clrMapOvr>
+    <a:masterClrMapping/>
+  </p:clrMapOvr>
+</p:sld>
+</file>
+
+<file path=ppt/slides/slide17.xml><?xml version="1.0" encoding="utf-8"?>
+<p:sld xmlns:a="http://schemas.openxmlformats.org/drawingml/2006/main" xmlns:r="http://schemas.openxmlformats.org/officeDocument/2006/relationships" xmlns:p="http://schemas.openxmlformats.org/presentationml/2006/main">
+  <p:cSld>
+    <p:spTree>
+      <p:nvGrpSpPr>
+        <p:cNvPr id="1" name=""/>
+        <p:cNvGrpSpPr/>
+        <p:nvPr/>
+      </p:nvGrpSpPr>
+      <p:grpSpPr>
+        <a:xfrm>
+          <a:off x="0" y="0"/>
+          <a:ext cx="0" cy="0"/>
+          <a:chOff x="0" y="0"/>
+          <a:chExt cx="0" cy="0"/>
+        </a:xfrm>
+      </p:grpSpPr>
+      <p:sp>
+        <p:nvSpPr>
+          <p:cNvPr id="2" name="Title 1"/>
+          <p:cNvSpPr>
+            <a:spLocks noGrp="1"/>
+          </p:cNvSpPr>
+          <p:nvPr>
+            <p:ph type="title"/>
+          </p:nvPr>
+        </p:nvSpPr>
+        <p:spPr/>
+        <p:txBody>
+          <a:bodyPr/>
+          <a:lstStyle/>
+          <a:p>
+            <a:r>
               <a:t>Deliverables and Next Steps</a:t>
             </a:r>
           </a:p>
@@ -3608,7 +4589,7 @@
         <p:spPr>
           <a:xfrm>
             <a:off x="8778240" y="2011680"/>
-            <a:ext cx="2926080" cy="4114800"/>
+            <a:ext cx="2910997" cy="3139321"/>
           </a:xfrm>
           <a:prstGeom prst="rect">
             <a:avLst/>
@@ -3616,28 +4597,31 @@
           <a:noFill/>
         </p:spPr>
         <p:txBody>
-          <a:bodyPr wrap="none">
+          <a:bodyPr wrap="square">
             <a:spAutoFit/>
           </a:bodyPr>
           <a:lstStyle/>
           <a:p>
             <a:r>
-              <a:t>Three release numbers drive everything: point (x, y, z), velocity vector, backspin rate.</a:t>
-            </a:r>
-          </a:p>
-          <a:p>
-            <a:endParaRPr/>
-          </a:p>
-          <a:p>
-            <a:r>
+              <a:rPr dirty="0"/>
+              <a:t>Three release numbers drive everything: point (x, y), velocity vector, backspin rate.</a:t>
+            </a:r>
+          </a:p>
+          <a:p>
+            <a:endParaRPr dirty="0"/>
+          </a:p>
+          <a:p>
+            <a:r>
+              <a:rPr dirty="0"/>
               <a:t>Gravity, quadratic air drag and Magnus lift shape the flight; the rigid board and rim decide every bounce.</a:t>
             </a:r>
           </a:p>
           <a:p>
-            <a:endParaRPr/>
-          </a:p>
-          <a:p>
-            <a:r>
+            <a:endParaRPr dirty="0"/>
+          </a:p>
+          <a:p>
+            <a:r>
+              <a:rPr dirty="0"/>
               <a:t>Pure physics, no training.</a:t>
             </a:r>
           </a:p>
@@ -3721,8 +4705,8 @@
         </p:nvSpPr>
         <p:spPr>
           <a:xfrm>
-            <a:off x="8778240" y="2011680"/>
-            <a:ext cx="2926080" cy="4114800"/>
+            <a:off x="8778239" y="2011679"/>
+            <a:ext cx="2760169" cy="3693319"/>
           </a:xfrm>
           <a:prstGeom prst="rect">
             <a:avLst/>
@@ -3730,28 +4714,43 @@
           <a:noFill/>
         </p:spPr>
         <p:txBody>
-          <a:bodyPr wrap="none">
+          <a:bodyPr wrap="square">
             <a:spAutoFit/>
           </a:bodyPr>
           <a:lstStyle/>
           <a:p>
             <a:r>
-              <a:t>OpenPose work (Cao 2017; Nakai et al. 2018) corrects the shooter's posture.</a:t>
-            </a:r>
-          </a:p>
-          <a:p>
-            <a:endParaRPr/>
-          </a:p>
-          <a:p>
-            <a:r>
-              <a:t>Classical models (Brancazio 1981; Okubo &amp; Hubbard 2006) drop backspin or fuse the bounce outcomes.</a:t>
-            </a:r>
-          </a:p>
-          <a:p>
-            <a:endParaRPr/>
-          </a:p>
-          <a:p>
-            <a:r>
+              <a:rPr dirty="0" err="1"/>
+              <a:t>OpenPose</a:t>
+            </a:r>
+            <a:r>
+              <a:rPr dirty="0"/>
+              <a:t> work (Cao 2017, Chen 2020) corrects the shooter's posture.</a:t>
+            </a:r>
+          </a:p>
+          <a:p>
+            <a:endParaRPr dirty="0"/>
+          </a:p>
+          <a:p>
+            <a:r>
+              <a:rPr dirty="0"/>
+              <a:t>Classical models (Brancazio 1981, </a:t>
+            </a:r>
+            <a:r>
+              <a:rPr dirty="0" err="1"/>
+              <a:t>Alaways</a:t>
+            </a:r>
+            <a:r>
+              <a:rPr dirty="0"/>
+              <a:t> and Hubbard 2002) drop backspin or fuse the bounce outcomes.</a:t>
+            </a:r>
+          </a:p>
+          <a:p>
+            <a:endParaRPr dirty="0"/>
+          </a:p>
+          <a:p>
+            <a:r>
+              <a:rPr dirty="0"/>
               <a:t>No study fills all five columns. That gap is our benchmark.</a:t>
             </a:r>
           </a:p>
@@ -3835,8 +4834,8 @@
         </p:nvSpPr>
         <p:spPr>
           <a:xfrm>
-            <a:off x="8778240" y="2011680"/>
-            <a:ext cx="2926080" cy="4114800"/>
+            <a:off x="8778240" y="2011679"/>
+            <a:ext cx="2779022" cy="2585323"/>
           </a:xfrm>
           <a:prstGeom prst="rect">
             <a:avLst/>
@@ -3844,20 +4843,22 @@
           <a:noFill/>
         </p:spPr>
         <p:txBody>
-          <a:bodyPr wrap="none">
+          <a:bodyPr wrap="square">
             <a:spAutoFit/>
           </a:bodyPr>
           <a:lstStyle/>
           <a:p>
             <a:r>
-              <a:t>Can a simulation with a rigid board, rigid rim and one restitution constant e = 0.7 reproduce swish, rim-in, board-in and miss?</a:t>
-            </a:r>
-          </a:p>
-          <a:p>
-            <a:endParaRPr/>
-          </a:p>
-          <a:p>
-            <a:r>
+              <a:rPr dirty="0"/>
+              <a:t>Can a simulation with a rigid board, rigid rim and one restitution constant e = 0.7 reproduce swish, board-and-in and miss?</a:t>
+            </a:r>
+          </a:p>
+          <a:p>
+            <a:endParaRPr dirty="0"/>
+          </a:p>
+          <a:p>
+            <a:r>
+              <a:rPr dirty="0"/>
               <a:t>Weight, v-squared drag and spin-driven Magnus lift are the only forces modelled.</a:t>
             </a:r>
           </a:p>
@@ -3941,8 +4942,8 @@
         </p:nvSpPr>
         <p:spPr>
           <a:xfrm>
-            <a:off x="8778240" y="2011680"/>
-            <a:ext cx="2926080" cy="4114800"/>
+            <a:off x="8778239" y="2011680"/>
+            <a:ext cx="2335963" cy="3970318"/>
           </a:xfrm>
           <a:prstGeom prst="rect">
             <a:avLst/>
@@ -3950,29 +4951,44 @@
           <a:noFill/>
         </p:spPr>
         <p:txBody>
-          <a:bodyPr wrap="none">
+          <a:bodyPr wrap="square">
             <a:spAutoFit/>
           </a:bodyPr>
           <a:lstStyle/>
           <a:p>
             <a:r>
-              <a:t>RK4 integration in Python and numpy.</a:t>
-            </a:r>
-          </a:p>
-          <a:p>
-            <a:endParaRPr/>
-          </a:p>
-          <a:p>
-            <a:r>
+              <a:rPr dirty="0"/>
+              <a:t>RK4 integration in Python and </a:t>
+            </a:r>
+            <a:r>
+              <a:rPr dirty="0" err="1"/>
+              <a:t>numpy</a:t>
+            </a:r>
+            <a:r>
+              <a:rPr dirty="0"/>
+              <a:t>.</a:t>
+            </a:r>
+          </a:p>
+          <a:p>
+            <a:endParaRPr dirty="0"/>
+          </a:p>
+          <a:p>
+            <a:r>
+              <a:rPr dirty="0"/>
               <a:t>Plane-sphere and circle-pair contacts, four labelled outcomes, then a sweep over angle and spin.</a:t>
             </a:r>
           </a:p>
           <a:p>
-            <a:endParaRPr/>
-          </a:p>
-          <a:p>
-            <a:r>
-              <a:t>SportVU plus our own filmed throws supply labels only; every constant stays frozen.</a:t>
+            <a:endParaRPr dirty="0"/>
+          </a:p>
+          <a:p>
+            <a:r>
+              <a:rPr dirty="0" err="1"/>
+              <a:t>SportVU</a:t>
+            </a:r>
+            <a:r>
+              <a:rPr dirty="0"/>
+              <a:t> plus our own filmed throws supply labels only; every constant stays frozen.</a:t>
             </a:r>
           </a:p>
         </p:txBody>
@@ -3986,7 +5002,7 @@
 </file>
 
 <file path=ppt/slides/slide6.xml><?xml version="1.0" encoding="utf-8"?>
-<p:sld xmlns:a="http://schemas.openxmlformats.org/drawingml/2006/main" xmlns:r="http://schemas.openxmlformats.org/officeDocument/2006/relationships" xmlns:p="http://schemas.openxmlformats.org/presentationml/2006/main">
+<p:sld xmlns:a="http://schemas.openxmlformats.org/drawingml/2006/main" xmlns:p="http://schemas.openxmlformats.org/presentationml/2006/main" xmlns:r="http://schemas.openxmlformats.org/officeDocument/2006/relationships">
   <p:cSld>
     <p:spTree>
       <p:nvGrpSpPr>
@@ -3994,14 +5010,7 @@
         <p:cNvGrpSpPr/>
         <p:nvPr/>
       </p:nvGrpSpPr>
-      <p:grpSpPr>
-        <a:xfrm>
-          <a:off x="0" y="0"/>
-          <a:ext cx="0" cy="0"/>
-          <a:chOff x="0" y="0"/>
-          <a:chExt cx="0" cy="0"/>
-        </a:xfrm>
-      </p:grpSpPr>
+      <p:grpSpPr/>
       <p:sp>
         <p:nvSpPr>
           <p:cNvPr id="2" name="Title 1"/>
@@ -4018,7 +5027,7 @@
           <a:lstStyle/>
           <a:p>
             <a:r>
-              <a:t>Scope Boundaries</a:t>
+              <a:t>Trajectory Equations (Model Function)</a:t>
             </a:r>
           </a:p>
         </p:txBody>
@@ -4030,7 +5039,7 @@
             <a:spLocks noGrp="1"/>
           </p:cNvSpPr>
           <p:nvPr>
-            <p:ph sz="half" idx="1"/>
+            <p:ph idx="1"/>
           </p:nvPr>
         </p:nvSpPr>
         <p:spPr/>
@@ -4039,78 +5048,92 @@
           <a:lstStyle/>
           <a:p>
             <a:r>
-              <a:t>Release point, velocity vector, backspin</a:t>
-            </a:r>
-          </a:p>
-          <a:p>
-            <a:r>
-              <a:t>Quadratic air drag + Magnus lift</a:t>
-            </a:r>
-          </a:p>
-          <a:p>
-            <a:r>
-              <a:t>Rigid vertical board plane</a:t>
-            </a:r>
-          </a:p>
-          <a:p>
-            <a:r>
-              <a:t>Rigid rim, inelastic contact e = 0.7</a:t>
-            </a:r>
-          </a:p>
-          <a:p>
-            <a:r>
-              <a:t>Swish, rim-in, board-in, miss</a:t>
-            </a:r>
-          </a:p>
-          <a:p>
-            <a:r>
-              <a:t>Free-throw versus 3-point extension</a:t>
-            </a:r>
-          </a:p>
-        </p:txBody>
-      </p:sp>
-      <p:sp>
-        <p:nvSpPr>
-          <p:cNvPr id="4" name="Content Placeholder 3"/>
-          <p:cNvSpPr>
-            <a:spLocks noGrp="1"/>
-          </p:cNvSpPr>
-          <p:nvPr>
-            <p:ph sz="half" idx="2"/>
-          </p:nvPr>
-        </p:nvSpPr>
-        <p:spPr/>
-        <p:txBody>
-          <a:bodyPr/>
-          <a:lstStyle/>
-          <a:p>
-            <a:r>
-              <a:t>Ball deformation, rim flex, board vibration</a:t>
-            </a:r>
-          </a:p>
-          <a:p>
-            <a:r>
-              <a:t>Player fatigue and psychology</a:t>
-            </a:r>
-          </a:p>
-          <a:p>
-            <a:r>
-              <a:t>Side-spin and wobble</a:t>
-            </a:r>
-          </a:p>
-          <a:p>
-            <a:r>
-              <a:t>Machine-learning correction of the physics</a:t>
-            </a:r>
-          </a:p>
-          <a:p>
-            <a:r>
-              <a:t>Real-time pose estimation</a:t>
-            </a:r>
-          </a:p>
-          <a:p>
-            <a:r>
-              <a:t>Claims about real players' performance</a:t>
+              <a:rPr sz="1500"/>
+              <a:t>State vector s = (x, y, vx, vy), released from (0, 2.00 m).</a:t>
+            </a:r>
+          </a:p>
+          <a:p>
+            <a:r>
+              <a:rPr sz="1500"/>
+              <a:t>dv/dt = g_vec + a_drag + a_magnus, with g_vec = (0, -9.81).</a:t>
+            </a:r>
+          </a:p>
+          <a:p>
+            <a:r>
+              <a:rPr sz="1500"/>
+              <a:t>Quadratic air drag, opposing velocity:</a:t>
+            </a:r>
+          </a:p>
+          <a:p>
+            <a:r>
+              <a:rPr sz="1500"/>
+              <a:t>   a_drag = -k |v| v,  k = 0.5 rho C_D A / m = 0.0213 per metre.</a:t>
+            </a:r>
+          </a:p>
+          <a:p>
+            <a:r>
+              <a:rPr sz="1500"/>
+              <a:t>Magnus force from backspin omega (spin axis out of plane):</a:t>
+            </a:r>
+          </a:p>
+          <a:p>
+            <a:r>
+              <a:rPr sz="1500"/>
+              <a:t>   a_magnus = C (omega x v),  C = 0.5 rho C_L A R / m = 1.09e-3.</a:t>
+            </a:r>
+          </a:p>
+          <a:p>
+            <a:r>
+              <a:rPr sz="1500"/>
+              <a:t>   Components:  ax = -C omega vy,  ay = +C omega vx.</a:t>
+            </a:r>
+          </a:p>
+          <a:p>
+            <a:r>
+              <a:rPr sz="1500"/>
+              <a:t>Vacuum closed form, used as a solver sanity check:</a:t>
+            </a:r>
+          </a:p>
+          <a:p>
+            <a:r>
+              <a:rPr sz="1500"/>
+              <a:t>   x(t) = v cos(theta) t,   y(t) = 2.00 + v sin(theta) t - 4.905 t^2.</a:t>
+            </a:r>
+          </a:p>
+          <a:p>
+            <a:r>
+              <a:rPr sz="1500"/>
+              <a:t>Reaching the rim plane x = d at height 3.05 fixes the no-air</a:t>
+            </a:r>
+          </a:p>
+          <a:p>
+            <a:r>
+              <a:rPr sz="1500"/>
+              <a:t>   minimum launch speed for that angle.</a:t>
+            </a:r>
+          </a:p>
+          <a:p>
+            <a:r>
+              <a:rPr sz="1500"/>
+              <a:t>Contacts: board = rigid vertical plane, rim = two circles;</a:t>
+            </a:r>
+          </a:p>
+          <a:p>
+            <a:r>
+              <a:rPr sz="1500"/>
+              <a:t>   post-bounce normal velocity scaled by e = 0.70, tangent by 0.85.</a:t>
+            </a:r>
+          </a:p>
+          <a:p>
+            <a:r>
+              <a:rPr sz="1500"/>
+              <a:t>Integrator: 4th-order Runge-Kutta, fixed 1 ms step, events checked</a:t>
+            </a:r>
+          </a:p>
+          <a:p>
+            <a:r>
+              <a:rPr sz="1500"/>
+              <a:t>   every step (plane crossing, distance to each rim edge).</a:t>
             </a:r>
           </a:p>
         </p:txBody>
@@ -4124,7 +5147,7 @@
 </file>
 
 <file path=ppt/slides/slide7.xml><?xml version="1.0" encoding="utf-8"?>
-<p:sld xmlns:a="http://schemas.openxmlformats.org/drawingml/2006/main" xmlns:r="http://schemas.openxmlformats.org/officeDocument/2006/relationships" xmlns:p="http://schemas.openxmlformats.org/presentationml/2006/main">
+<p:sld xmlns:a="http://schemas.openxmlformats.org/drawingml/2006/main" xmlns:p="http://schemas.openxmlformats.org/presentationml/2006/main" xmlns:r="http://schemas.openxmlformats.org/officeDocument/2006/relationships">
   <p:cSld>
     <p:spTree>
       <p:nvGrpSpPr>
@@ -4132,14 +5155,7 @@
         <p:cNvGrpSpPr/>
         <p:nvPr/>
       </p:nvGrpSpPr>
-      <p:grpSpPr>
-        <a:xfrm>
-          <a:off x="0" y="0"/>
-          <a:ext cx="0" cy="0"/>
-          <a:chOff x="0" y="0"/>
-          <a:chExt cx="0" cy="0"/>
-        </a:xfrm>
-      </p:grpSpPr>
+      <p:grpSpPr/>
       <p:sp>
         <p:nvSpPr>
           <p:cNvPr id="2" name="Title 1"/>
@@ -4156,14 +5172,1850 @@
           <a:lstStyle/>
           <a:p>
             <a:r>
-              <a:t>Early Result: Make-Probability Surface</a:t>
+              <a:t>Model Parameters (frozen, not tuned)</a:t>
+            </a:r>
+          </a:p>
+        </p:txBody>
+      </p:sp>
+      <p:graphicFrame>
+        <p:nvGraphicFramePr>
+          <p:cNvPr id="3" name="Table 2"/>
+          <p:cNvGraphicFramePr>
+            <a:graphicFrameLocks noGrp="1"/>
+          </p:cNvGraphicFramePr>
+          <p:nvPr/>
+        </p:nvGraphicFramePr>
+        <p:xfrm>
+          <a:off x="457200" y="1584000"/>
+          <a:ext cx="11016000" cy="3240000"/>
+        </p:xfrm>
+        <a:graphic>
+          <a:graphicData uri="http://schemas.openxmlformats.org/drawingml/2006/table">
+            <a:tbl>
+              <a:tblPr firstRow="1" bandRow="1">
+                <a:tableStyleId>{5C22544A-7EE6-4342-B048-85BDC9FD1C3A}</a:tableStyleId>
+              </a:tblPr>
+              <a:tblGrid>
+                <a:gridCol w="2160000"/>
+                <a:gridCol w="5256000"/>
+                <a:gridCol w="3600000"/>
+              </a:tblGrid>
+              <a:tr h="249230">
+                <a:tc>
+                  <a:txBody>
+                    <a:bodyPr/>
+                    <a:lstStyle/>
+                    <a:p>
+                      <a:r>
+                        <a:rPr b="1" sz="1100"/>
+                        <a:t>Symbol</a:t>
+                      </a:r>
+                    </a:p>
+                  </a:txBody>
+                  <a:tcPr/>
+                </a:tc>
+                <a:tc>
+                  <a:txBody>
+                    <a:bodyPr/>
+                    <a:lstStyle/>
+                    <a:p>
+                      <a:r>
+                        <a:rPr b="1" sz="1100"/>
+                        <a:t>Quantity</a:t>
+                      </a:r>
+                    </a:p>
+                  </a:txBody>
+                  <a:tcPr/>
+                </a:tc>
+                <a:tc>
+                  <a:txBody>
+                    <a:bodyPr/>
+                    <a:lstStyle/>
+                    <a:p>
+                      <a:r>
+                        <a:rPr b="1" sz="1100"/>
+                        <a:t>Value</a:t>
+                      </a:r>
+                    </a:p>
+                  </a:txBody>
+                  <a:tcPr/>
+                </a:tc>
+              </a:tr>
+              <a:tr h="249230">
+                <a:tc>
+                  <a:txBody>
+                    <a:bodyPr/>
+                    <a:lstStyle/>
+                    <a:p>
+                      <a:r>
+                        <a:rPr sz="1100"/>
+                        <a:t>m</a:t>
+                      </a:r>
+                    </a:p>
+                  </a:txBody>
+                  <a:tcPr/>
+                </a:tc>
+                <a:tc>
+                  <a:txBody>
+                    <a:bodyPr/>
+                    <a:lstStyle/>
+                    <a:p>
+                      <a:r>
+                        <a:rPr sz="1100"/>
+                        <a:t>ball mass</a:t>
+                      </a:r>
+                    </a:p>
+                  </a:txBody>
+                  <a:tcPr/>
+                </a:tc>
+                <a:tc>
+                  <a:txBody>
+                    <a:bodyPr/>
+                    <a:lstStyle/>
+                    <a:p>
+                      <a:r>
+                        <a:rPr sz="1100"/>
+                        <a:t>0.60 kg</a:t>
+                      </a:r>
+                    </a:p>
+                  </a:txBody>
+                  <a:tcPr/>
+                </a:tc>
+              </a:tr>
+              <a:tr h="249230">
+                <a:tc>
+                  <a:txBody>
+                    <a:bodyPr/>
+                    <a:lstStyle/>
+                    <a:p>
+                      <a:r>
+                        <a:rPr sz="1100"/>
+                        <a:t>R</a:t>
+                      </a:r>
+                    </a:p>
+                  </a:txBody>
+                  <a:tcPr/>
+                </a:tc>
+                <a:tc>
+                  <a:txBody>
+                    <a:bodyPr/>
+                    <a:lstStyle/>
+                    <a:p>
+                      <a:r>
+                        <a:rPr sz="1100"/>
+                        <a:t>ball radius</a:t>
+                      </a:r>
+                    </a:p>
+                  </a:txBody>
+                  <a:tcPr/>
+                </a:tc>
+                <a:tc>
+                  <a:txBody>
+                    <a:bodyPr/>
+                    <a:lstStyle/>
+                    <a:p>
+                      <a:r>
+                        <a:rPr sz="1100"/>
+                        <a:t>0.12 m</a:t>
+                      </a:r>
+                    </a:p>
+                  </a:txBody>
+                  <a:tcPr/>
+                </a:tc>
+              </a:tr>
+              <a:tr h="249230">
+                <a:tc>
+                  <a:txBody>
+                    <a:bodyPr/>
+                    <a:lstStyle/>
+                    <a:p>
+                      <a:r>
+                        <a:rPr sz="1100"/>
+                        <a:t>A</a:t>
+                      </a:r>
+                    </a:p>
+                  </a:txBody>
+                  <a:tcPr/>
+                </a:tc>
+                <a:tc>
+                  <a:txBody>
+                    <a:bodyPr/>
+                    <a:lstStyle/>
+                    <a:p>
+                      <a:r>
+                        <a:rPr sz="1100"/>
+                        <a:t>cross-sectional area</a:t>
+                      </a:r>
+                    </a:p>
+                  </a:txBody>
+                  <a:tcPr/>
+                </a:tc>
+                <a:tc>
+                  <a:txBody>
+                    <a:bodyPr/>
+                    <a:lstStyle/>
+                    <a:p>
+                      <a:r>
+                        <a:rPr sz="1100"/>
+                        <a:t>4.52e-2 m^2</a:t>
+                      </a:r>
+                    </a:p>
+                  </a:txBody>
+                  <a:tcPr/>
+                </a:tc>
+              </a:tr>
+              <a:tr h="249230">
+                <a:tc>
+                  <a:txBody>
+                    <a:bodyPr/>
+                    <a:lstStyle/>
+                    <a:p>
+                      <a:r>
+                        <a:rPr sz="1100"/>
+                        <a:t>g</a:t>
+                      </a:r>
+                    </a:p>
+                  </a:txBody>
+                  <a:tcPr/>
+                </a:tc>
+                <a:tc>
+                  <a:txBody>
+                    <a:bodyPr/>
+                    <a:lstStyle/>
+                    <a:p>
+                      <a:r>
+                        <a:rPr sz="1100"/>
+                        <a:t>gravity</a:t>
+                      </a:r>
+                    </a:p>
+                  </a:txBody>
+                  <a:tcPr/>
+                </a:tc>
+                <a:tc>
+                  <a:txBody>
+                    <a:bodyPr/>
+                    <a:lstStyle/>
+                    <a:p>
+                      <a:r>
+                        <a:rPr sz="1100"/>
+                        <a:t>9.81 m/s^2</a:t>
+                      </a:r>
+                    </a:p>
+                  </a:txBody>
+                  <a:tcPr/>
+                </a:tc>
+              </a:tr>
+              <a:tr h="249230">
+                <a:tc>
+                  <a:txBody>
+                    <a:bodyPr/>
+                    <a:lstStyle/>
+                    <a:p>
+                      <a:r>
+                        <a:rPr sz="1100"/>
+                        <a:t>C_D</a:t>
+                      </a:r>
+                    </a:p>
+                  </a:txBody>
+                  <a:tcPr/>
+                </a:tc>
+                <a:tc>
+                  <a:txBody>
+                    <a:bodyPr/>
+                    <a:lstStyle/>
+                    <a:p>
+                      <a:r>
+                        <a:rPr sz="1100"/>
+                        <a:t>drag coefficient</a:t>
+                      </a:r>
+                    </a:p>
+                  </a:txBody>
+                  <a:tcPr/>
+                </a:tc>
+                <a:tc>
+                  <a:txBody>
+                    <a:bodyPr/>
+                    <a:lstStyle/>
+                    <a:p>
+                      <a:r>
+                        <a:rPr sz="1100"/>
+                        <a:t>0.47</a:t>
+                      </a:r>
+                    </a:p>
+                  </a:txBody>
+                  <a:tcPr/>
+                </a:tc>
+              </a:tr>
+              <a:tr h="249230">
+                <a:tc>
+                  <a:txBody>
+                    <a:bodyPr/>
+                    <a:lstStyle/>
+                    <a:p>
+                      <a:r>
+                        <a:rPr sz="1100"/>
+                        <a:t>C_L</a:t>
+                      </a:r>
+                    </a:p>
+                  </a:txBody>
+                  <a:tcPr/>
+                </a:tc>
+                <a:tc>
+                  <a:txBody>
+                    <a:bodyPr/>
+                    <a:lstStyle/>
+                    <a:p>
+                      <a:r>
+                        <a:rPr sz="1100"/>
+                        <a:t>Magnus (spin-lift) coefficient</a:t>
+                      </a:r>
+                    </a:p>
+                  </a:txBody>
+                  <a:tcPr/>
+                </a:tc>
+                <a:tc>
+                  <a:txBody>
+                    <a:bodyPr/>
+                    <a:lstStyle/>
+                    <a:p>
+                      <a:r>
+                        <a:rPr sz="1100"/>
+                        <a:t>0.20</a:t>
+                      </a:r>
+                    </a:p>
+                  </a:txBody>
+                  <a:tcPr/>
+                </a:tc>
+              </a:tr>
+              <a:tr h="249230">
+                <a:tc>
+                  <a:txBody>
+                    <a:bodyPr/>
+                    <a:lstStyle/>
+                    <a:p>
+                      <a:r>
+                        <a:rPr sz="1100"/>
+                        <a:t>rho</a:t>
+                      </a:r>
+                    </a:p>
+                  </a:txBody>
+                  <a:tcPr/>
+                </a:tc>
+                <a:tc>
+                  <a:txBody>
+                    <a:bodyPr/>
+                    <a:lstStyle/>
+                    <a:p>
+                      <a:r>
+                        <a:rPr sz="1100"/>
+                        <a:t>air density (20 C, sea level)</a:t>
+                      </a:r>
+                    </a:p>
+                  </a:txBody>
+                  <a:tcPr/>
+                </a:tc>
+                <a:tc>
+                  <a:txBody>
+                    <a:bodyPr/>
+                    <a:lstStyle/>
+                    <a:p>
+                      <a:r>
+                        <a:rPr sz="1100"/>
+                        <a:t>1.204 kg/m^3</a:t>
+                      </a:r>
+                    </a:p>
+                  </a:txBody>
+                  <a:tcPr/>
+                </a:tc>
+              </a:tr>
+              <a:tr h="249230">
+                <a:tc>
+                  <a:txBody>
+                    <a:bodyPr/>
+                    <a:lstStyle/>
+                    <a:p>
+                      <a:r>
+                        <a:rPr sz="1100"/>
+                        <a:t>e</a:t>
+                      </a:r>
+                    </a:p>
+                  </a:txBody>
+                  <a:tcPr/>
+                </a:tc>
+                <a:tc>
+                  <a:txBody>
+                    <a:bodyPr/>
+                    <a:lstStyle/>
+                    <a:p>
+                      <a:r>
+                        <a:rPr sz="1100"/>
+                        <a:t>restitution, board and rim</a:t>
+                      </a:r>
+                    </a:p>
+                  </a:txBody>
+                  <a:tcPr/>
+                </a:tc>
+                <a:tc>
+                  <a:txBody>
+                    <a:bodyPr/>
+                    <a:lstStyle/>
+                    <a:p>
+                      <a:r>
+                        <a:rPr sz="1100"/>
+                        <a:t>0.70</a:t>
+                      </a:r>
+                    </a:p>
+                  </a:txBody>
+                  <a:tcPr/>
+                </a:tc>
+              </a:tr>
+              <a:tr h="249230">
+                <a:tc>
+                  <a:txBody>
+                    <a:bodyPr/>
+                    <a:lstStyle/>
+                    <a:p>
+                      <a:r>
+                        <a:rPr sz="1100"/>
+                        <a:t>rim r</a:t>
+                      </a:r>
+                    </a:p>
+                  </a:txBody>
+                  <a:tcPr/>
+                </a:tc>
+                <a:tc>
+                  <a:txBody>
+                    <a:bodyPr/>
+                    <a:lstStyle/>
+                    <a:p>
+                      <a:r>
+                        <a:rPr sz="1100"/>
+                        <a:t>rim inner radius / plane height</a:t>
+                      </a:r>
+                    </a:p>
+                  </a:txBody>
+                  <a:tcPr/>
+                </a:tc>
+                <a:tc>
+                  <a:txBody>
+                    <a:bodyPr/>
+                    <a:lstStyle/>
+                    <a:p>
+                      <a:r>
+                        <a:rPr sz="1100"/>
+                        <a:t>0.229 m / 3.05 m</a:t>
+                      </a:r>
+                    </a:p>
+                  </a:txBody>
+                  <a:tcPr/>
+                </a:tc>
+              </a:tr>
+              <a:tr h="249230">
+                <a:tc>
+                  <a:txBody>
+                    <a:bodyPr/>
+                    <a:lstStyle/>
+                    <a:p>
+                      <a:r>
+                        <a:rPr sz="1100"/>
+                        <a:t>dist</a:t>
+                      </a:r>
+                    </a:p>
+                  </a:txBody>
+                  <a:tcPr/>
+                </a:tc>
+                <a:tc>
+                  <a:txBody>
+                    <a:bodyPr/>
+                    <a:lstStyle/>
+                    <a:p>
+                      <a:r>
+                        <a:rPr sz="1100"/>
+                        <a:t>release to rim plane</a:t>
+                      </a:r>
+                    </a:p>
+                  </a:txBody>
+                  <a:tcPr/>
+                </a:tc>
+                <a:tc>
+                  <a:txBody>
+                    <a:bodyPr/>
+                    <a:lstStyle/>
+                    <a:p>
+                      <a:r>
+                        <a:rPr sz="1100"/>
+                        <a:t>4.60 m FT, 6.75 m 3PT</a:t>
+                      </a:r>
+                    </a:p>
+                  </a:txBody>
+                  <a:tcPr/>
+                </a:tc>
+              </a:tr>
+              <a:tr h="249230">
+                <a:tc>
+                  <a:txBody>
+                    <a:bodyPr/>
+                    <a:lstStyle/>
+                    <a:p>
+                      <a:r>
+                        <a:rPr sz="1100"/>
+                        <a:t>omega</a:t>
+                      </a:r>
+                    </a:p>
+                  </a:txBody>
+                  <a:tcPr/>
+                </a:tc>
+                <a:tc>
+                  <a:txBody>
+                    <a:bodyPr/>
+                    <a:lstStyle/>
+                    <a:p>
+                      <a:r>
+                        <a:rPr sz="1100"/>
+                        <a:t>backspin rate, swept</a:t>
+                      </a:r>
+                    </a:p>
+                  </a:txBody>
+                  <a:tcPr/>
+                </a:tc>
+                <a:tc>
+                  <a:txBody>
+                    <a:bodyPr/>
+                    <a:lstStyle/>
+                    <a:p>
+                      <a:r>
+                        <a:rPr sz="1100"/>
+                        <a:t>0 to 40 rad/s</a:t>
+                      </a:r>
+                    </a:p>
+                  </a:txBody>
+                  <a:tcPr/>
+                </a:tc>
+              </a:tr>
+              <a:tr h="249240">
+                <a:tc>
+                  <a:txBody>
+                    <a:bodyPr/>
+                    <a:lstStyle/>
+                    <a:p>
+                      <a:r>
+                        <a:rPr sz="1100"/>
+                        <a:t>dt</a:t>
+                      </a:r>
+                    </a:p>
+                  </a:txBody>
+                  <a:tcPr/>
+                </a:tc>
+                <a:tc>
+                  <a:txBody>
+                    <a:bodyPr/>
+                    <a:lstStyle/>
+                    <a:p>
+                      <a:r>
+                        <a:rPr sz="1100"/>
+                        <a:t>RK4 integration step</a:t>
+                      </a:r>
+                    </a:p>
+                  </a:txBody>
+                  <a:tcPr/>
+                </a:tc>
+                <a:tc>
+                  <a:txBody>
+                    <a:bodyPr/>
+                    <a:lstStyle/>
+                    <a:p>
+                      <a:r>
+                        <a:rPr sz="1100"/>
+                        <a:t>1.0 ms</a:t>
+                      </a:r>
+                    </a:p>
+                  </a:txBody>
+                  <a:tcPr/>
+                </a:tc>
+              </a:tr>
+            </a:tbl>
+          </a:graphicData>
+        </a:graphic>
+      </p:graphicFrame>
+      <p:sp>
+        <p:nvSpPr>
+          <p:cNvPr id="4" name="TextBox 3"/>
+          <p:cNvSpPr txBox="1"/>
+          <p:nvPr/>
+        </p:nvSpPr>
+        <p:spPr>
+          <a:xfrm>
+            <a:off x="457200" y="5004000"/>
+            <a:ext cx="11016000" cy="2160000"/>
+          </a:xfrm>
+          <a:prstGeom prst="rect">
+            <a:avLst/>
+          </a:prstGeom>
+          <a:noFill/>
+        </p:spPr>
+        <p:txBody>
+          <a:bodyPr wrap="square">
+            <a:spAutoFit/>
+          </a:bodyPr>
+          <a:lstStyle/>
+          <a:p>
+            <a:r>
+              <a:rPr sz="1200"/>
+              <a:t>k = 0.0213 per metre and rho C_L A R / 2m = 1.09e-3 are the</a:t>
+            </a:r>
+          </a:p>
+          <a:p>
+            <a:r>
+              <a:rPr sz="1200"/>
+              <a:t>only two prefactors that enter dv/dt. All constants stay frozen.</a:t>
+            </a:r>
+          </a:p>
+        </p:txBody>
+      </p:sp>
+    </p:spTree>
+  </p:cSld>
+  <p:clrMapOvr>
+    <a:masterClrMapping/>
+  </p:clrMapOvr>
+</p:sld>
+</file>
+
+<file path=ppt/slides/slide8.xml><?xml version="1.0" encoding="utf-8"?>
+<p:sld xmlns:a="http://schemas.openxmlformats.org/drawingml/2006/main" xmlns:p="http://schemas.openxmlformats.org/presentationml/2006/main" xmlns:r="http://schemas.openxmlformats.org/officeDocument/2006/relationships">
+  <p:cSld>
+    <p:spTree>
+      <p:nvGrpSpPr>
+        <p:cNvPr id="1" name=""/>
+        <p:cNvGrpSpPr/>
+        <p:nvPr/>
+      </p:nvGrpSpPr>
+      <p:grpSpPr/>
+      <p:sp>
+        <p:nvSpPr>
+          <p:cNvPr id="2" name="Title 1"/>
+          <p:cNvSpPr>
+            <a:spLocks noGrp="1"/>
+          </p:cNvSpPr>
+          <p:nvPr>
+            <p:ph type="title"/>
+          </p:nvPr>
+        </p:nvSpPr>
+        <p:spPr/>
+        <p:txBody>
+          <a:bodyPr/>
+          <a:lstStyle/>
+          <a:p>
+            <a:r>
+              <a:t>Representative Flight Data (release height 2.0 m)</a:t>
+            </a:r>
+          </a:p>
+        </p:txBody>
+      </p:sp>
+      <p:graphicFrame>
+        <p:nvGraphicFramePr>
+          <p:cNvPr id="3" name="Table 2"/>
+          <p:cNvGraphicFramePr>
+            <a:graphicFrameLocks noGrp="1"/>
+          </p:cNvGraphicFramePr>
+          <p:nvPr/>
+        </p:nvGraphicFramePr>
+        <p:xfrm>
+          <a:off x="457200" y="1584000"/>
+          <a:ext cx="10835999" cy="3240000"/>
+        </p:xfrm>
+        <a:graphic>
+          <a:graphicData uri="http://schemas.openxmlformats.org/drawingml/2006/table">
+            <a:tbl>
+              <a:tblPr firstRow="1" bandRow="1">
+                <a:tableStyleId>{5C22544A-7EE6-4342-B048-85BDC9FD1C3A}</a:tableStyleId>
+              </a:tblPr>
+              <a:tblGrid>
+                <a:gridCol w="2520000"/>
+                <a:gridCol w="684000"/>
+                <a:gridCol w="684000"/>
+                <a:gridCol w="1512000"/>
+                <a:gridCol w="936000"/>
+                <a:gridCol w="1007999"/>
+                <a:gridCol w="1044000"/>
+                <a:gridCol w="1080000"/>
+                <a:gridCol w="1368000"/>
+              </a:tblGrid>
+              <a:tr h="360000">
+                <a:tc>
+                  <a:txBody>
+                    <a:bodyPr/>
+                    <a:lstStyle/>
+                    <a:p>
+                      <a:r>
+                        <a:rPr b="1" sz="1100"/>
+                        <a:t>Shot</a:t>
+                      </a:r>
+                    </a:p>
+                  </a:txBody>
+                  <a:tcPr/>
+                </a:tc>
+                <a:tc>
+                  <a:txBody>
+                    <a:bodyPr/>
+                    <a:lstStyle/>
+                    <a:p>
+                      <a:r>
+                        <a:rPr b="1" sz="1100"/>
+                        <a:t>Angle</a:t>
+                      </a:r>
+                    </a:p>
+                  </a:txBody>
+                  <a:tcPr/>
+                </a:tc>
+                <a:tc>
+                  <a:txBody>
+                    <a:bodyPr/>
+                    <a:lstStyle/>
+                    <a:p>
+                      <a:r>
+                        <a:rPr b="1" sz="1100"/>
+                        <a:t>Spin</a:t>
+                      </a:r>
+                    </a:p>
+                  </a:txBody>
+                  <a:tcPr/>
+                </a:tc>
+                <a:tc>
+                  <a:txBody>
+                    <a:bodyPr/>
+                    <a:lstStyle/>
+                    <a:p>
+                      <a:r>
+                        <a:rPr b="1" sz="1100"/>
+                        <a:t>Speed window to score</a:t>
+                      </a:r>
+                    </a:p>
+                  </a:txBody>
+                  <a:tcPr/>
+                </a:tc>
+                <a:tc>
+                  <a:txBody>
+                    <a:bodyPr/>
+                    <a:lstStyle/>
+                    <a:p>
+                      <a:r>
+                        <a:rPr b="1" sz="1100"/>
+                        <a:t>Window</a:t>
+                      </a:r>
+                    </a:p>
+                  </a:txBody>
+                  <a:tcPr/>
+                </a:tc>
+                <a:tc>
+                  <a:txBody>
+                    <a:bodyPr/>
+                    <a:lstStyle/>
+                    <a:p>
+                      <a:r>
+                        <a:rPr b="1" sz="1100"/>
+                        <a:t>Rep speed</a:t>
+                      </a:r>
+                    </a:p>
+                  </a:txBody>
+                  <a:tcPr/>
+                </a:tc>
+                <a:tc>
+                  <a:txBody>
+                    <a:bodyPr/>
+                    <a:lstStyle/>
+                    <a:p>
+                      <a:r>
+                        <a:rPr b="1" sz="1100"/>
+                        <a:t>Hang time</a:t>
+                      </a:r>
+                    </a:p>
+                  </a:txBody>
+                  <a:tcPr/>
+                </a:tc>
+                <a:tc>
+                  <a:txBody>
+                    <a:bodyPr/>
+                    <a:lstStyle/>
+                    <a:p>
+                      <a:r>
+                        <a:rPr b="1" sz="1100"/>
+                        <a:t>Entry angle</a:t>
+                      </a:r>
+                    </a:p>
+                  </a:txBody>
+                  <a:tcPr/>
+                </a:tc>
+                <a:tc>
+                  <a:txBody>
+                    <a:bodyPr/>
+                    <a:lstStyle/>
+                    <a:p>
+                      <a:r>
+                        <a:rPr b="1" sz="1100"/>
+                        <a:t>Apex above rim</a:t>
+                      </a:r>
+                    </a:p>
+                  </a:txBody>
+                  <a:tcPr/>
+                </a:tc>
+              </a:tr>
+              <a:tr h="360000">
+                <a:tc>
+                  <a:txBody>
+                    <a:bodyPr/>
+                    <a:lstStyle/>
+                    <a:p>
+                      <a:r>
+                        <a:rPr sz="1100"/>
+                        <a:t>Free throw, no spin</a:t>
+                      </a:r>
+                    </a:p>
+                  </a:txBody>
+                  <a:tcPr/>
+                </a:tc>
+                <a:tc>
+                  <a:txBody>
+                    <a:bodyPr/>
+                    <a:lstStyle/>
+                    <a:p>
+                      <a:r>
+                        <a:rPr sz="1100"/>
+                        <a:t>45</a:t>
+                      </a:r>
+                    </a:p>
+                  </a:txBody>
+                  <a:tcPr/>
+                </a:tc>
+                <a:tc>
+                  <a:txBody>
+                    <a:bodyPr/>
+                    <a:lstStyle/>
+                    <a:p>
+                      <a:r>
+                        <a:rPr sz="1100"/>
+                        <a:t>0</a:t>
+                      </a:r>
+                    </a:p>
+                  </a:txBody>
+                  <a:tcPr/>
+                </a:tc>
+                <a:tc>
+                  <a:txBody>
+                    <a:bodyPr/>
+                    <a:lstStyle/>
+                    <a:p>
+                      <a:r>
+                        <a:rPr sz="1100"/>
+                        <a:t>7.99-8.02</a:t>
+                      </a:r>
+                    </a:p>
+                  </a:txBody>
+                  <a:tcPr/>
+                </a:tc>
+                <a:tc>
+                  <a:txBody>
+                    <a:bodyPr/>
+                    <a:lstStyle/>
+                    <a:p>
+                      <a:r>
+                        <a:rPr sz="1100"/>
+                        <a:t>0.03</a:t>
+                      </a:r>
+                    </a:p>
+                  </a:txBody>
+                  <a:tcPr/>
+                </a:tc>
+                <a:tc>
+                  <a:txBody>
+                    <a:bodyPr/>
+                    <a:lstStyle/>
+                    <a:p>
+                      <a:r>
+                        <a:rPr sz="1100"/>
+                        <a:t>7.99</a:t>
+                      </a:r>
+                    </a:p>
+                  </a:txBody>
+                  <a:tcPr/>
+                </a:tc>
+                <a:tc>
+                  <a:txBody>
+                    <a:bodyPr/>
+                    <a:lstStyle/>
+                    <a:p>
+                      <a:r>
+                        <a:rPr sz="1100"/>
+                        <a:t>0.87 s</a:t>
+                      </a:r>
+                    </a:p>
+                  </a:txBody>
+                  <a:tcPr/>
+                </a:tc>
+                <a:tc>
+                  <a:txBody>
+                    <a:bodyPr/>
+                    <a:lstStyle/>
+                    <a:p>
+                      <a:r>
+                        <a:rPr sz="1100"/>
+                        <a:t>31 deg</a:t>
+                      </a:r>
+                    </a:p>
+                  </a:txBody>
+                  <a:tcPr/>
+                </a:tc>
+                <a:tc>
+                  <a:txBody>
+                    <a:bodyPr/>
+                    <a:lstStyle/>
+                    <a:p>
+                      <a:r>
+                        <a:rPr sz="1100"/>
+                        <a:t>0.49 m</a:t>
+                      </a:r>
+                    </a:p>
+                  </a:txBody>
+                  <a:tcPr/>
+                </a:tc>
+              </a:tr>
+              <a:tr h="360000">
+                <a:tc>
+                  <a:txBody>
+                    <a:bodyPr/>
+                    <a:lstStyle/>
+                    <a:p>
+                      <a:r>
+                        <a:rPr sz="1100"/>
+                        <a:t>Free throw, backspin</a:t>
+                      </a:r>
+                    </a:p>
+                  </a:txBody>
+                  <a:tcPr/>
+                </a:tc>
+                <a:tc>
+                  <a:txBody>
+                    <a:bodyPr/>
+                    <a:lstStyle/>
+                    <a:p>
+                      <a:r>
+                        <a:rPr sz="1100"/>
+                        <a:t>45</a:t>
+                      </a:r>
+                    </a:p>
+                  </a:txBody>
+                  <a:tcPr/>
+                </a:tc>
+                <a:tc>
+                  <a:txBody>
+                    <a:bodyPr/>
+                    <a:lstStyle/>
+                    <a:p>
+                      <a:r>
+                        <a:rPr sz="1100"/>
+                        <a:t>23</a:t>
+                      </a:r>
+                    </a:p>
+                  </a:txBody>
+                  <a:tcPr/>
+                </a:tc>
+                <a:tc>
+                  <a:txBody>
+                    <a:bodyPr/>
+                    <a:lstStyle/>
+                    <a:p>
+                      <a:r>
+                        <a:rPr sz="1100"/>
+                        <a:t>8.02-8.05</a:t>
+                      </a:r>
+                    </a:p>
+                  </a:txBody>
+                  <a:tcPr/>
+                </a:tc>
+                <a:tc>
+                  <a:txBody>
+                    <a:bodyPr/>
+                    <a:lstStyle/>
+                    <a:p>
+                      <a:r>
+                        <a:rPr sz="1100"/>
+                        <a:t>0.03</a:t>
+                      </a:r>
+                    </a:p>
+                  </a:txBody>
+                  <a:tcPr/>
+                </a:tc>
+                <a:tc>
+                  <a:txBody>
+                    <a:bodyPr/>
+                    <a:lstStyle/>
+                    <a:p>
+                      <a:r>
+                        <a:rPr sz="1100"/>
+                        <a:t>8.02</a:t>
+                      </a:r>
+                    </a:p>
+                  </a:txBody>
+                  <a:tcPr/>
+                </a:tc>
+                <a:tc>
+                  <a:txBody>
+                    <a:bodyPr/>
+                    <a:lstStyle/>
+                    <a:p>
+                      <a:r>
+                        <a:rPr sz="1100"/>
+                        <a:t>0.87 s</a:t>
+                      </a:r>
+                    </a:p>
+                  </a:txBody>
+                  <a:tcPr/>
+                </a:tc>
+                <a:tc>
+                  <a:txBody>
+                    <a:bodyPr/>
+                    <a:lstStyle/>
+                    <a:p>
+                      <a:r>
+                        <a:rPr sz="1100"/>
+                        <a:t>31 deg</a:t>
+                      </a:r>
+                    </a:p>
+                  </a:txBody>
+                  <a:tcPr/>
+                </a:tc>
+                <a:tc>
+                  <a:txBody>
+                    <a:bodyPr/>
+                    <a:lstStyle/>
+                    <a:p>
+                      <a:r>
+                        <a:rPr sz="1100"/>
+                        <a:t>0.48 m</a:t>
+                      </a:r>
+                    </a:p>
+                  </a:txBody>
+                  <a:tcPr/>
+                </a:tc>
+              </a:tr>
+              <a:tr h="360000">
+                <a:tc>
+                  <a:txBody>
+                    <a:bodyPr/>
+                    <a:lstStyle/>
+                    <a:p>
+                      <a:r>
+                        <a:rPr sz="1100"/>
+                        <a:t>Free throw, peak region</a:t>
+                      </a:r>
+                    </a:p>
+                  </a:txBody>
+                  <a:tcPr/>
+                </a:tc>
+                <a:tc>
+                  <a:txBody>
+                    <a:bodyPr/>
+                    <a:lstStyle/>
+                    <a:p>
+                      <a:r>
+                        <a:rPr sz="1100"/>
+                        <a:t>51</a:t>
+                      </a:r>
+                    </a:p>
+                  </a:txBody>
+                  <a:tcPr/>
+                </a:tc>
+                <a:tc>
+                  <a:txBody>
+                    <a:bodyPr/>
+                    <a:lstStyle/>
+                    <a:p>
+                      <a:r>
+                        <a:rPr sz="1100"/>
+                        <a:t>23</a:t>
+                      </a:r>
+                    </a:p>
+                  </a:txBody>
+                  <a:tcPr/>
+                </a:tc>
+                <a:tc>
+                  <a:txBody>
+                    <a:bodyPr/>
+                    <a:lstStyle/>
+                    <a:p>
+                      <a:r>
+                        <a:rPr sz="1100"/>
+                        <a:t>7.87-7.93</a:t>
+                      </a:r>
+                    </a:p>
+                  </a:txBody>
+                  <a:tcPr/>
+                </a:tc>
+                <a:tc>
+                  <a:txBody>
+                    <a:bodyPr/>
+                    <a:lstStyle/>
+                    <a:p>
+                      <a:r>
+                        <a:rPr sz="1100"/>
+                        <a:t>0.06</a:t>
+                      </a:r>
+                    </a:p>
+                  </a:txBody>
+                  <a:tcPr/>
+                </a:tc>
+                <a:tc>
+                  <a:txBody>
+                    <a:bodyPr/>
+                    <a:lstStyle/>
+                    <a:p>
+                      <a:r>
+                        <a:rPr sz="1100"/>
+                        <a:t>7.90</a:t>
+                      </a:r>
+                    </a:p>
+                  </a:txBody>
+                  <a:tcPr/>
+                </a:tc>
+                <a:tc>
+                  <a:txBody>
+                    <a:bodyPr/>
+                    <a:lstStyle/>
+                    <a:p>
+                      <a:r>
+                        <a:rPr sz="1100"/>
+                        <a:t>0.99 s</a:t>
+                      </a:r>
+                    </a:p>
+                  </a:txBody>
+                  <a:tcPr/>
+                </a:tc>
+                <a:tc>
+                  <a:txBody>
+                    <a:bodyPr/>
+                    <a:lstStyle/>
+                    <a:p>
+                      <a:r>
+                        <a:rPr sz="1100"/>
+                        <a:t>41 deg</a:t>
+                      </a:r>
+                    </a:p>
+                  </a:txBody>
+                  <a:tcPr/>
+                </a:tc>
+                <a:tc>
+                  <a:txBody>
+                    <a:bodyPr/>
+                    <a:lstStyle/>
+                    <a:p>
+                      <a:r>
+                        <a:rPr sz="1100"/>
+                        <a:t>0.75 m</a:t>
+                      </a:r>
+                    </a:p>
+                  </a:txBody>
+                  <a:tcPr/>
+                </a:tc>
+              </a:tr>
+              <a:tr h="360000">
+                <a:tc>
+                  <a:txBody>
+                    <a:bodyPr/>
+                    <a:lstStyle/>
+                    <a:p>
+                      <a:r>
+                        <a:rPr sz="1100"/>
+                        <a:t>Free throw, steep</a:t>
+                      </a:r>
+                    </a:p>
+                  </a:txBody>
+                  <a:tcPr/>
+                </a:tc>
+                <a:tc>
+                  <a:txBody>
+                    <a:bodyPr/>
+                    <a:lstStyle/>
+                    <a:p>
+                      <a:r>
+                        <a:rPr sz="1100"/>
+                        <a:t>54</a:t>
+                      </a:r>
+                    </a:p>
+                  </a:txBody>
+                  <a:tcPr/>
+                </a:tc>
+                <a:tc>
+                  <a:txBody>
+                    <a:bodyPr/>
+                    <a:lstStyle/>
+                    <a:p>
+                      <a:r>
+                        <a:rPr sz="1100"/>
+                        <a:t>23</a:t>
+                      </a:r>
+                    </a:p>
+                  </a:txBody>
+                  <a:tcPr/>
+                </a:tc>
+                <a:tc>
+                  <a:txBody>
+                    <a:bodyPr/>
+                    <a:lstStyle/>
+                    <a:p>
+                      <a:r>
+                        <a:rPr sz="1100"/>
+                        <a:t>7.87-7.96</a:t>
+                      </a:r>
+                    </a:p>
+                  </a:txBody>
+                  <a:tcPr/>
+                </a:tc>
+                <a:tc>
+                  <a:txBody>
+                    <a:bodyPr/>
+                    <a:lstStyle/>
+                    <a:p>
+                      <a:r>
+                        <a:rPr sz="1100"/>
+                        <a:t>0.09</a:t>
+                      </a:r>
+                    </a:p>
+                  </a:txBody>
+                  <a:tcPr/>
+                </a:tc>
+                <a:tc>
+                  <a:txBody>
+                    <a:bodyPr/>
+                    <a:lstStyle/>
+                    <a:p>
+                      <a:r>
+                        <a:rPr sz="1100"/>
+                        <a:t>7.90</a:t>
+                      </a:r>
+                    </a:p>
+                  </a:txBody>
+                  <a:tcPr/>
+                </a:tc>
+                <a:tc>
+                  <a:txBody>
+                    <a:bodyPr/>
+                    <a:lstStyle/>
+                    <a:p>
+                      <a:r>
+                        <a:rPr sz="1100"/>
+                        <a:t>1.05 s</a:t>
+                      </a:r>
+                    </a:p>
+                  </a:txBody>
+                  <a:tcPr/>
+                </a:tc>
+                <a:tc>
+                  <a:txBody>
+                    <a:bodyPr/>
+                    <a:lstStyle/>
+                    <a:p>
+                      <a:r>
+                        <a:rPr sz="1100"/>
+                        <a:t>45 deg</a:t>
+                      </a:r>
+                    </a:p>
+                  </a:txBody>
+                  <a:tcPr/>
+                </a:tc>
+                <a:tc>
+                  <a:txBody>
+                    <a:bodyPr/>
+                    <a:lstStyle/>
+                    <a:p>
+                      <a:r>
+                        <a:rPr sz="1100"/>
+                        <a:t>0.89 m</a:t>
+                      </a:r>
+                    </a:p>
+                  </a:txBody>
+                  <a:tcPr/>
+                </a:tc>
+              </a:tr>
+              <a:tr h="360000">
+                <a:tc>
+                  <a:txBody>
+                    <a:bodyPr/>
+                    <a:lstStyle/>
+                    <a:p>
+                      <a:r>
+                        <a:rPr sz="1100"/>
+                        <a:t>Bank shot</a:t>
+                      </a:r>
+                    </a:p>
+                  </a:txBody>
+                  <a:tcPr/>
+                </a:tc>
+                <a:tc>
+                  <a:txBody>
+                    <a:bodyPr/>
+                    <a:lstStyle/>
+                    <a:p>
+                      <a:r>
+                        <a:rPr sz="1100"/>
+                        <a:t>45</a:t>
+                      </a:r>
+                    </a:p>
+                  </a:txBody>
+                  <a:tcPr/>
+                </a:tc>
+                <a:tc>
+                  <a:txBody>
+                    <a:bodyPr/>
+                    <a:lstStyle/>
+                    <a:p>
+                      <a:r>
+                        <a:rPr sz="1100"/>
+                        <a:t>23</a:t>
+                      </a:r>
+                    </a:p>
+                  </a:txBody>
+                  <a:tcPr/>
+                </a:tc>
+                <a:tc>
+                  <a:txBody>
+                    <a:bodyPr/>
+                    <a:lstStyle/>
+                    <a:p>
+                      <a:r>
+                        <a:rPr sz="1100"/>
+                        <a:t>8.38-8.47</a:t>
+                      </a:r>
+                    </a:p>
+                  </a:txBody>
+                  <a:tcPr/>
+                </a:tc>
+                <a:tc>
+                  <a:txBody>
+                    <a:bodyPr/>
+                    <a:lstStyle/>
+                    <a:p>
+                      <a:r>
+                        <a:rPr sz="1100"/>
+                        <a:t>0.09</a:t>
+                      </a:r>
+                    </a:p>
+                  </a:txBody>
+                  <a:tcPr/>
+                </a:tc>
+                <a:tc>
+                  <a:txBody>
+                    <a:bodyPr/>
+                    <a:lstStyle/>
+                    <a:p>
+                      <a:r>
+                        <a:rPr sz="1100"/>
+                        <a:t>8.41</a:t>
+                      </a:r>
+                    </a:p>
+                  </a:txBody>
+                  <a:tcPr/>
+                </a:tc>
+                <a:tc>
+                  <a:txBody>
+                    <a:bodyPr/>
+                    <a:lstStyle/>
+                    <a:p>
+                      <a:r>
+                        <a:rPr sz="1100"/>
+                        <a:t>0.94 s</a:t>
+                      </a:r>
+                    </a:p>
+                  </a:txBody>
+                  <a:tcPr/>
+                </a:tc>
+                <a:tc>
+                  <a:txBody>
+                    <a:bodyPr/>
+                    <a:lstStyle/>
+                    <a:p>
+                      <a:r>
+                        <a:rPr sz="1100"/>
+                        <a:t>40 deg</a:t>
+                      </a:r>
+                    </a:p>
+                  </a:txBody>
+                  <a:tcPr/>
+                </a:tc>
+                <a:tc>
+                  <a:txBody>
+                    <a:bodyPr/>
+                    <a:lstStyle/>
+                    <a:p>
+                      <a:r>
+                        <a:rPr sz="1100"/>
+                        <a:t>0.63 m</a:t>
+                      </a:r>
+                    </a:p>
+                  </a:txBody>
+                  <a:tcPr/>
+                </a:tc>
+              </a:tr>
+              <a:tr h="360000">
+                <a:tc>
+                  <a:txBody>
+                    <a:bodyPr/>
+                    <a:lstStyle/>
+                    <a:p>
+                      <a:r>
+                        <a:rPr sz="1100"/>
+                        <a:t>Bank shot, steep</a:t>
+                      </a:r>
+                    </a:p>
+                  </a:txBody>
+                  <a:tcPr/>
+                </a:tc>
+                <a:tc>
+                  <a:txBody>
+                    <a:bodyPr/>
+                    <a:lstStyle/>
+                    <a:p>
+                      <a:r>
+                        <a:rPr sz="1100"/>
+                        <a:t>57</a:t>
+                      </a:r>
+                    </a:p>
+                  </a:txBody>
+                  <a:tcPr/>
+                </a:tc>
+                <a:tc>
+                  <a:txBody>
+                    <a:bodyPr/>
+                    <a:lstStyle/>
+                    <a:p>
+                      <a:r>
+                        <a:rPr sz="1100"/>
+                        <a:t>23</a:t>
+                      </a:r>
+                    </a:p>
+                  </a:txBody>
+                  <a:tcPr/>
+                </a:tc>
+                <a:tc>
+                  <a:txBody>
+                    <a:bodyPr/>
+                    <a:lstStyle/>
+                    <a:p>
+                      <a:r>
+                        <a:rPr sz="1100"/>
+                        <a:t>8.38-8.56</a:t>
+                      </a:r>
+                    </a:p>
+                  </a:txBody>
+                  <a:tcPr/>
+                </a:tc>
+                <a:tc>
+                  <a:txBody>
+                    <a:bodyPr/>
+                    <a:lstStyle/>
+                    <a:p>
+                      <a:r>
+                        <a:rPr sz="1100"/>
+                        <a:t>0.18</a:t>
+                      </a:r>
+                    </a:p>
+                  </a:txBody>
+                  <a:tcPr/>
+                </a:tc>
+                <a:tc>
+                  <a:txBody>
+                    <a:bodyPr/>
+                    <a:lstStyle/>
+                    <a:p>
+                      <a:r>
+                        <a:rPr sz="1100"/>
+                        <a:t>8.47</a:t>
+                      </a:r>
+                    </a:p>
+                  </a:txBody>
+                  <a:tcPr/>
+                </a:tc>
+                <a:tc>
+                  <a:txBody>
+                    <a:bodyPr/>
+                    <a:lstStyle/>
+                    <a:p>
+                      <a:r>
+                        <a:rPr sz="1100"/>
+                        <a:t>1.22 s</a:t>
+                      </a:r>
+                    </a:p>
+                  </a:txBody>
+                  <a:tcPr/>
+                </a:tc>
+                <a:tc>
+                  <a:txBody>
+                    <a:bodyPr/>
+                    <a:lstStyle/>
+                    <a:p>
+                      <a:r>
+                        <a:rPr sz="1100"/>
+                        <a:t>58 deg</a:t>
+                      </a:r>
+                    </a:p>
+                  </a:txBody>
+                  <a:tcPr/>
+                </a:tc>
+                <a:tc>
+                  <a:txBody>
+                    <a:bodyPr/>
+                    <a:lstStyle/>
+                    <a:p>
+                      <a:r>
+                        <a:rPr sz="1100"/>
+                        <a:t>1.33 m</a:t>
+                      </a:r>
+                    </a:p>
+                  </a:txBody>
+                  <a:tcPr/>
+                </a:tc>
+              </a:tr>
+              <a:tr h="360000">
+                <a:tc>
+                  <a:txBody>
+                    <a:bodyPr/>
+                    <a:lstStyle/>
+                    <a:p>
+                      <a:r>
+                        <a:rPr sz="1100"/>
+                        <a:t>Three-point, flat</a:t>
+                      </a:r>
+                    </a:p>
+                  </a:txBody>
+                  <a:tcPr/>
+                </a:tc>
+                <a:tc>
+                  <a:txBody>
+                    <a:bodyPr/>
+                    <a:lstStyle/>
+                    <a:p>
+                      <a:r>
+                        <a:rPr sz="1100"/>
+                        <a:t>45</a:t>
+                      </a:r>
+                    </a:p>
+                  </a:txBody>
+                  <a:tcPr/>
+                </a:tc>
+                <a:tc>
+                  <a:txBody>
+                    <a:bodyPr/>
+                    <a:lstStyle/>
+                    <a:p>
+                      <a:r>
+                        <a:rPr sz="1100"/>
+                        <a:t>23</a:t>
+                      </a:r>
+                    </a:p>
+                  </a:txBody>
+                  <a:tcPr/>
+                </a:tc>
+                <a:tc>
+                  <a:txBody>
+                    <a:bodyPr/>
+                    <a:lstStyle/>
+                    <a:p>
+                      <a:r>
+                        <a:rPr sz="1100"/>
+                        <a:t>9.43-9.49</a:t>
+                      </a:r>
+                    </a:p>
+                  </a:txBody>
+                  <a:tcPr/>
+                </a:tc>
+                <a:tc>
+                  <a:txBody>
+                    <a:bodyPr/>
+                    <a:lstStyle/>
+                    <a:p>
+                      <a:r>
+                        <a:rPr sz="1100"/>
+                        <a:t>0.06</a:t>
+                      </a:r>
+                    </a:p>
+                  </a:txBody>
+                  <a:tcPr/>
+                </a:tc>
+                <a:tc>
+                  <a:txBody>
+                    <a:bodyPr/>
+                    <a:lstStyle/>
+                    <a:p>
+                      <a:r>
+                        <a:rPr sz="1100"/>
+                        <a:t>9.46</a:t>
+                      </a:r>
+                    </a:p>
+                  </a:txBody>
+                  <a:tcPr/>
+                </a:tc>
+                <a:tc>
+                  <a:txBody>
+                    <a:bodyPr/>
+                    <a:lstStyle/>
+                    <a:p>
+                      <a:r>
+                        <a:rPr sz="1100"/>
+                        <a:t>1.10 s</a:t>
+                      </a:r>
+                    </a:p>
+                  </a:txBody>
+                  <a:tcPr/>
+                </a:tc>
+                <a:tc>
+                  <a:txBody>
+                    <a:bodyPr/>
+                    <a:lstStyle/>
+                    <a:p>
+                      <a:r>
+                        <a:rPr sz="1100"/>
+                        <a:t>38 deg</a:t>
+                      </a:r>
+                    </a:p>
+                  </a:txBody>
+                  <a:tcPr/>
+                </a:tc>
+                <a:tc>
+                  <a:txBody>
+                    <a:bodyPr/>
+                    <a:lstStyle/>
+                    <a:p>
+                      <a:r>
+                        <a:rPr sz="1100"/>
+                        <a:t>1.04 m</a:t>
+                      </a:r>
+                    </a:p>
+                  </a:txBody>
+                  <a:tcPr/>
+                </a:tc>
+              </a:tr>
+              <a:tr h="360000">
+                <a:tc>
+                  <a:txBody>
+                    <a:bodyPr/>
+                    <a:lstStyle/>
+                    <a:p>
+                      <a:r>
+                        <a:rPr sz="1100"/>
+                        <a:t>Three-point, peak</a:t>
+                      </a:r>
+                    </a:p>
+                  </a:txBody>
+                  <a:tcPr/>
+                </a:tc>
+                <a:tc>
+                  <a:txBody>
+                    <a:bodyPr/>
+                    <a:lstStyle/>
+                    <a:p>
+                      <a:r>
+                        <a:rPr sz="1100"/>
+                        <a:t>51</a:t>
+                      </a:r>
+                    </a:p>
+                  </a:txBody>
+                  <a:tcPr/>
+                </a:tc>
+                <a:tc>
+                  <a:txBody>
+                    <a:bodyPr/>
+                    <a:lstStyle/>
+                    <a:p>
+                      <a:r>
+                        <a:rPr sz="1100"/>
+                        <a:t>23</a:t>
+                      </a:r>
+                    </a:p>
+                  </a:txBody>
+                  <a:tcPr/>
+                </a:tc>
+                <a:tc>
+                  <a:txBody>
+                    <a:bodyPr/>
+                    <a:lstStyle/>
+                    <a:p>
+                      <a:r>
+                        <a:rPr sz="1100"/>
+                        <a:t>9.37-9.46</a:t>
+                      </a:r>
+                    </a:p>
+                  </a:txBody>
+                  <a:tcPr/>
+                </a:tc>
+                <a:tc>
+                  <a:txBody>
+                    <a:bodyPr/>
+                    <a:lstStyle/>
+                    <a:p>
+                      <a:r>
+                        <a:rPr sz="1100"/>
+                        <a:t>0.09</a:t>
+                      </a:r>
+                    </a:p>
+                  </a:txBody>
+                  <a:tcPr/>
+                </a:tc>
+                <a:tc>
+                  <a:txBody>
+                    <a:bodyPr/>
+                    <a:lstStyle/>
+                    <a:p>
+                      <a:r>
+                        <a:rPr sz="1100"/>
+                        <a:t>9.40</a:t>
+                      </a:r>
+                    </a:p>
+                  </a:txBody>
+                  <a:tcPr/>
+                </a:tc>
+                <a:tc>
+                  <a:txBody>
+                    <a:bodyPr/>
+                    <a:lstStyle/>
+                    <a:p>
+                      <a:r>
+                        <a:rPr sz="1100"/>
+                        <a:t>1.24 s</a:t>
+                      </a:r>
+                    </a:p>
+                  </a:txBody>
+                  <a:tcPr/>
+                </a:tc>
+                <a:tc>
+                  <a:txBody>
+                    <a:bodyPr/>
+                    <a:lstStyle/>
+                    <a:p>
+                      <a:r>
+                        <a:rPr sz="1100"/>
+                        <a:t>46 deg</a:t>
+                      </a:r>
+                    </a:p>
+                  </a:txBody>
+                  <a:tcPr/>
+                </a:tc>
+                <a:tc>
+                  <a:txBody>
+                    <a:bodyPr/>
+                    <a:lstStyle/>
+                    <a:p>
+                      <a:r>
+                        <a:rPr sz="1100"/>
+                        <a:t>1.44 m</a:t>
+                      </a:r>
+                    </a:p>
+                  </a:txBody>
+                  <a:tcPr/>
+                </a:tc>
+              </a:tr>
+            </a:tbl>
+          </a:graphicData>
+        </a:graphic>
+      </p:graphicFrame>
+      <p:sp>
+        <p:nvSpPr>
+          <p:cNvPr id="4" name="TextBox 3"/>
+          <p:cNvSpPr txBox="1"/>
+          <p:nvPr/>
+        </p:nvSpPr>
+        <p:spPr>
+          <a:xfrm>
+            <a:off x="457200" y="5004000"/>
+            <a:ext cx="11016000" cy="2160000"/>
+          </a:xfrm>
+          <a:prstGeom prst="rect">
+            <a:avLst/>
+          </a:prstGeom>
+          <a:noFill/>
+        </p:spPr>
+        <p:txBody>
+          <a:bodyPr wrap="square">
+            <a:spAutoFit/>
+          </a:bodyPr>
+          <a:lstStyle/>
+          <a:p>
+            <a:r>
+              <a:rPr sz="1200"/>
+              <a:t>Window = the launch speeds that produce a clean swish or a clean bank-in,</a:t>
+            </a:r>
+          </a:p>
+          <a:p>
+            <a:r>
+              <a:rPr sz="1200"/>
+              <a:t>found by a 0.03 m/s grid sweep of the RK4 model; wider window means more</a:t>
+            </a:r>
+          </a:p>
+          <a:p>
+            <a:r>
+              <a:rPr sz="1200"/>
+              <a:t>tolerance to launch-speed error. The 57 deg steep bank has the widest</a:t>
+            </a:r>
+          </a:p>
+          <a:p>
+            <a:r>
+              <a:rPr sz="1200"/>
+              <a:t>single band (0.18 m/s), but the combined Monte-Carlo make rate over angle</a:t>
+            </a:r>
+          </a:p>
+          <a:p>
+            <a:r>
+              <a:rPr sz="1200"/>
+              <a:t>and spin still peaks near 51 deg at 23 rad/s, as reported in the</a:t>
+            </a:r>
+          </a:p>
+          <a:p>
+            <a:r>
+              <a:rPr sz="1200"/>
+              <a:t>Early Result slide (peak P = 0.86).</a:t>
+            </a:r>
+          </a:p>
+        </p:txBody>
+      </p:sp>
+    </p:spTree>
+  </p:cSld>
+  <p:clrMapOvr>
+    <a:masterClrMapping/>
+  </p:clrMapOvr>
+</p:sld>
+</file>
+
+<file path=ppt/slides/slide9.xml><?xml version="1.0" encoding="utf-8"?>
+<p:sld xmlns:a="http://schemas.openxmlformats.org/drawingml/2006/main" xmlns:p="http://schemas.openxmlformats.org/presentationml/2006/main" xmlns:r="http://schemas.openxmlformats.org/officeDocument/2006/relationships">
+  <p:cSld>
+    <p:spTree>
+      <p:nvGrpSpPr>
+        <p:cNvPr id="1" name=""/>
+        <p:cNvGrpSpPr/>
+        <p:nvPr/>
+      </p:nvGrpSpPr>
+      <p:grpSpPr/>
+      <p:sp>
+        <p:nvSpPr>
+          <p:cNvPr id="2" name="Title 1"/>
+          <p:cNvSpPr>
+            <a:spLocks noGrp="1"/>
+          </p:cNvSpPr>
+          <p:nvPr>
+            <p:ph type="title"/>
+          </p:nvPr>
+        </p:nvSpPr>
+        <p:spPr/>
+        <p:txBody>
+          <a:bodyPr/>
+          <a:lstStyle/>
+          <a:p>
+            <a:r>
+              <a:t>Simulated Trajectories</a:t>
             </a:r>
           </a:p>
         </p:txBody>
       </p:sp>
       <p:pic>
         <p:nvPicPr>
-          <p:cNvPr id="3" name="Picture 2" descr="fig_heatmap.png"/>
+          <p:cNvPr id="3" name="Picture 2" descr="traj_paths.png"/>
           <p:cNvPicPr>
             <a:picLocks noChangeAspect="1"/>
           </p:cNvPicPr>
@@ -4177,8 +7029,8 @@
         </p:blipFill>
         <p:spPr>
           <a:xfrm>
-            <a:off x="731520" y="1645920"/>
-            <a:ext cx="7772400" cy="4739268"/>
+            <a:off x="730799" y="1655999"/>
+            <a:ext cx="7740000" cy="4341951"/>
           </a:xfrm>
           <a:prstGeom prst="rect">
             <a:avLst/>
@@ -4193,8 +7045,8 @@
         </p:nvSpPr>
         <p:spPr>
           <a:xfrm>
-            <a:off x="8778240" y="2011680"/>
-            <a:ext cx="2926080" cy="4114800"/>
+            <a:off x="8748000" y="1800000"/>
+            <a:ext cx="3024000" cy="4320000"/>
           </a:xfrm>
           <a:prstGeom prst="rect">
             <a:avLst/>
@@ -4202,257 +7054,44 @@
           <a:noFill/>
         </p:spPr>
         <p:txBody>
-          <a:bodyPr wrap="none">
+          <a:bodyPr wrap="square">
             <a:spAutoFit/>
           </a:bodyPr>
           <a:lstStyle/>
           <a:p>
             <a:r>
-              <a:t>Grid sweep: 17 angles x 17 spin rates, 100 jittered shots per cell.</a:t>
-            </a:r>
-          </a:p>
-          <a:p>
-            <a:endParaRPr/>
-          </a:p>
-          <a:p>
-            <a:r>
-              <a:t>Peak P(make) ≈ 0.77 near 55° with 45 rad/s of backspin, split across swish / rim-in / board-in.</a:t>
-            </a:r>
-          </a:p>
-          <a:p>
-            <a:endParaRPr/>
-          </a:p>
-          <a:p>
-            <a:r>
-              <a:t>Without spin P is lower, rising to a broad plateau (~15–45 rad/s).</a:t>
-            </a:r>
-          </a:p>
-        </p:txBody>
-      </p:sp>
-    </p:spTree>
-  </p:cSld>
-  <p:clrMapOvr>
-    <a:masterClrMapping/>
-  </p:clrMapOvr>
-</p:sld>
-</file>
-
-<file path=ppt/slides/slide8.xml><?xml version="1.0" encoding="utf-8"?>
-<p:sld xmlns:a="http://schemas.openxmlformats.org/drawingml/2006/main" xmlns:r="http://schemas.openxmlformats.org/officeDocument/2006/relationships" xmlns:p="http://schemas.openxmlformats.org/presentationml/2006/main">
-  <p:cSld>
-    <p:spTree>
-      <p:nvGrpSpPr>
-        <p:cNvPr id="1" name=""/>
-        <p:cNvGrpSpPr/>
-        <p:nvPr/>
-      </p:nvGrpSpPr>
-      <p:grpSpPr>
-        <a:xfrm>
-          <a:off x="0" y="0"/>
-          <a:ext cx="0" cy="0"/>
-          <a:chOff x="0" y="0"/>
-          <a:chExt cx="0" cy="0"/>
-        </a:xfrm>
-      </p:grpSpPr>
-      <p:sp>
-        <p:nvSpPr>
-          <p:cNvPr id="2" name="Title 1"/>
-          <p:cNvSpPr>
-            <a:spLocks noGrp="1"/>
-          </p:cNvSpPr>
-          <p:nvPr>
-            <p:ph type="title"/>
-          </p:nvPr>
-        </p:nvSpPr>
-        <p:spPr/>
-        <p:txBody>
-          <a:bodyPr/>
-          <a:lstStyle/>
-          <a:p>
-            <a:r>
-              <a:t>Extension: Free Throw versus 3-Point</a:t>
-            </a:r>
-          </a:p>
-        </p:txBody>
-      </p:sp>
-      <p:pic>
-        <p:nvPicPr>
-          <p:cNvPr id="3" name="Picture 2" descr="fig_ft3p.png"/>
-          <p:cNvPicPr>
-            <a:picLocks noChangeAspect="1"/>
-          </p:cNvPicPr>
-          <p:nvPr/>
-        </p:nvPicPr>
-        <p:blipFill>
-          <a:blip r:embed="rId2"/>
-          <a:stretch>
-            <a:fillRect/>
-          </a:stretch>
-        </p:blipFill>
-        <p:spPr>
-          <a:xfrm>
-            <a:off x="731520" y="1645920"/>
-            <a:ext cx="7772400" cy="4739268"/>
-          </a:xfrm>
-          <a:prstGeom prst="rect">
-            <a:avLst/>
-          </a:prstGeom>
-        </p:spPr>
-      </p:pic>
-      <p:sp>
-        <p:nvSpPr>
-          <p:cNvPr id="4" name="TextBox 3"/>
-          <p:cNvSpPr txBox="1"/>
-          <p:nvPr/>
-        </p:nvSpPr>
-        <p:spPr>
-          <a:xfrm>
-            <a:off x="8778240" y="2011680"/>
-            <a:ext cx="2926080" cy="4114800"/>
-          </a:xfrm>
-          <a:prstGeom prst="rect">
-            <a:avLst/>
-          </a:prstGeom>
-          <a:noFill/>
-        </p:spPr>
-        <p:txBody>
-          <a:bodyPr wrap="none">
-            <a:spAutoFit/>
-          </a:bodyPr>
-          <a:lstStyle/>
-          <a:p>
-            <a:r>
-              <a:t>Air costs extra launch speed, and more at longer range.</a:t>
-            </a:r>
-          </a:p>
-          <a:p>
-            <a:endParaRPr/>
-          </a:p>
-          <a:p>
-            <a:r>
-              <a:t>Aim as if in a vacuum and the ball reaches the rim plane low: 40.2 cm on a free throw, 117 cm from three-point range.</a:t>
-            </a:r>
-          </a:p>
-          <a:p>
-            <a:endParaRPr/>
-          </a:p>
-          <a:p>
-            <a:r>
-              <a:t>Drag and spin matter more the farther the shot.</a:t>
-            </a:r>
-          </a:p>
-        </p:txBody>
-      </p:sp>
-    </p:spTree>
-  </p:cSld>
-  <p:clrMapOvr>
-    <a:masterClrMapping/>
-  </p:clrMapOvr>
-</p:sld>
-</file>
-
-<file path=ppt/slides/slide9.xml><?xml version="1.0" encoding="utf-8"?>
-<p:sld xmlns:a="http://schemas.openxmlformats.org/drawingml/2006/main" xmlns:r="http://schemas.openxmlformats.org/officeDocument/2006/relationships" xmlns:p="http://schemas.openxmlformats.org/presentationml/2006/main">
-  <p:cSld>
-    <p:spTree>
-      <p:nvGrpSpPr>
-        <p:cNvPr id="1" name=""/>
-        <p:cNvGrpSpPr/>
-        <p:nvPr/>
-      </p:nvGrpSpPr>
-      <p:grpSpPr>
-        <a:xfrm>
-          <a:off x="0" y="0"/>
-          <a:ext cx="0" cy="0"/>
-          <a:chOff x="0" y="0"/>
-          <a:chExt cx="0" cy="0"/>
-        </a:xfrm>
-      </p:grpSpPr>
-      <p:sp>
-        <p:nvSpPr>
-          <p:cNvPr id="2" name="Title 1"/>
-          <p:cNvSpPr>
-            <a:spLocks noGrp="1"/>
-          </p:cNvSpPr>
-          <p:nvPr>
-            <p:ph type="title"/>
-          </p:nvPr>
-        </p:nvSpPr>
-        <p:spPr/>
-        <p:txBody>
-          <a:bodyPr/>
-          <a:lstStyle/>
-          <a:p>
-            <a:r>
-              <a:t>Validation Design</a:t>
-            </a:r>
-          </a:p>
-        </p:txBody>
-      </p:sp>
-      <p:pic>
-        <p:nvPicPr>
-          <p:cNvPr id="3" name="Picture 2" descr="fig_validation.png"/>
-          <p:cNvPicPr>
-            <a:picLocks noChangeAspect="1"/>
-          </p:cNvPicPr>
-          <p:nvPr/>
-        </p:nvPicPr>
-        <p:blipFill>
-          <a:blip r:embed="rId2"/>
-          <a:stretch>
-            <a:fillRect/>
-          </a:stretch>
-        </p:blipFill>
-        <p:spPr>
-          <a:xfrm>
-            <a:off x="731520" y="1645920"/>
-            <a:ext cx="7772400" cy="4739268"/>
-          </a:xfrm>
-          <a:prstGeom prst="rect">
-            <a:avLst/>
-          </a:prstGeom>
-        </p:spPr>
-      </p:pic>
-      <p:sp>
-        <p:nvSpPr>
-          <p:cNvPr id="4" name="TextBox 3"/>
-          <p:cNvSpPr txBox="1"/>
-          <p:nvPr/>
-        </p:nvSpPr>
-        <p:spPr>
-          <a:xfrm>
-            <a:off x="8778240" y="2011680"/>
-            <a:ext cx="2926080" cy="4114800"/>
-          </a:xfrm>
-          <a:prstGeom prst="rect">
-            <a:avLst/>
-          </a:prstGeom>
-          <a:noFill/>
-        </p:spPr>
-        <p:txBody>
-          <a:bodyPr wrap="none">
-            <a:spAutoFit/>
-          </a:bodyPr>
-          <a:lstStyle/>
-          <a:p>
-            <a:r>
-              <a:t>20 to 30 group-member free throws filmed at 60 fps, plus public NBA SportVU tracking.</a:t>
-            </a:r>
-          </a:p>
-          <a:p>
-            <a:endParaRPr/>
-          </a:p>
-          <a:p>
-            <a:r>
-              <a:t>Frame by frame tracking gives release geometry and the recorded outcome class.</a:t>
-            </a:r>
-          </a:p>
-          <a:p>
-            <a:endParaRPr/>
-          </a:p>
-          <a:p>
-            <a:r>
-              <a:t>We report a single disagreement rate, as a sanity check rather than a statistical claim.</a:t>
+              <a:rPr sz="1200"/>
+              <a:t>Solid curves are representative mid-window shots from the RK4</a:t>
+            </a:r>
+          </a:p>
+          <a:p>
+            <a:r>
+              <a:rPr sz="1200"/>
+              <a:t>model; the dotted arcs repeat the same aim with air removed.</a:t>
+            </a:r>
+          </a:p>
+          <a:p>
+            <a:r>
+              <a:rPr sz="1200"/>
+              <a:t>With no air the ball meets the rim-centre plane about 32 cm</a:t>
+            </a:r>
+          </a:p>
+          <a:p>
+            <a:r>
+              <a:rPr sz="1200"/>
+              <a:t>below the rim on a free throw and 75 cm below from three-point</a:t>
+            </a:r>
+          </a:p>
+          <a:p>
+            <a:r>
+              <a:rPr sz="1200"/>
+              <a:t>range, so aiming as if in a vacuum lands low - the basis of the</a:t>
+            </a:r>
+          </a:p>
+          <a:p>
+            <a:r>
+              <a:rPr sz="1200"/>
+              <a:t>distance-extension result. Drag and spin scale with flight length.</a:t>
             </a:r>
           </a:p>
         </p:txBody>

</xml_diff>